<commit_message>
Reemplazar la demo Python por una consola C# sin dependencias adicionales
</commit_message>
<xml_diff>
--- a/Documentos/Presentacion/TurnosLavadero-Grupo9.pptx
+++ b/Documentos/Presentacion/TurnosLavadero-Grupo9.pptx
@@ -2,27 +2,27 @@
 <file path=ppt/presentation.xml><?xml version="1.0" encoding="utf-8"?>
 <p:presentation xmlns:p="http://schemas.openxmlformats.org/presentationml/2006/main">
   <p:sldMasterIdLst>
-    <p:sldMasterId xmlns:r="http://schemas.openxmlformats.org/officeDocument/2006/relationships" id="2147483648" r:id="R9a65d37cdf1c43fd"/>
+    <p:sldMasterId xmlns:r="http://schemas.openxmlformats.org/officeDocument/2006/relationships" id="2147483648" r:id="R9e61a96477f3402a"/>
   </p:sldMasterIdLst>
   <p:notesMasterIdLst>
-    <p:notesMasterId xmlns:r="http://schemas.openxmlformats.org/officeDocument/2006/relationships" r:id="R0870c67ea1a94814"/>
+    <p:notesMasterId xmlns:r="http://schemas.openxmlformats.org/officeDocument/2006/relationships" r:id="R4b2067f0fa77421e"/>
   </p:notesMasterIdLst>
   <p:sldIdLst>
-    <p:sldId xmlns:r="http://schemas.openxmlformats.org/officeDocument/2006/relationships" id="256" r:id="Rfe68a9f68f9844d8"/>
-    <p:sldId xmlns:r="http://schemas.openxmlformats.org/officeDocument/2006/relationships" id="257" r:id="R0f63d54e188248e9"/>
-    <p:sldId xmlns:r="http://schemas.openxmlformats.org/officeDocument/2006/relationships" id="258" r:id="R442f9b14e6b84706"/>
-    <p:sldId xmlns:r="http://schemas.openxmlformats.org/officeDocument/2006/relationships" id="259" r:id="R516073cb06234ae8"/>
-    <p:sldId xmlns:r="http://schemas.openxmlformats.org/officeDocument/2006/relationships" id="260" r:id="R805d1fd9934344da"/>
-    <p:sldId xmlns:r="http://schemas.openxmlformats.org/officeDocument/2006/relationships" id="261" r:id="R8e4767cdfb92455b"/>
-    <p:sldId xmlns:r="http://schemas.openxmlformats.org/officeDocument/2006/relationships" id="262" r:id="R34ad550042514f7f"/>
-    <p:sldId xmlns:r="http://schemas.openxmlformats.org/officeDocument/2006/relationships" id="263" r:id="Re10785ca0ca44611"/>
-    <p:sldId xmlns:r="http://schemas.openxmlformats.org/officeDocument/2006/relationships" id="264" r:id="R1e15bf24e927460a"/>
-    <p:sldId xmlns:r="http://schemas.openxmlformats.org/officeDocument/2006/relationships" id="265" r:id="R2662023c7a4f48e4"/>
-    <p:sldId xmlns:r="http://schemas.openxmlformats.org/officeDocument/2006/relationships" id="266" r:id="Rd92fe394fb094d72"/>
-    <p:sldId xmlns:r="http://schemas.openxmlformats.org/officeDocument/2006/relationships" id="267" r:id="Rddd09db3b599484b"/>
-    <p:sldId xmlns:r="http://schemas.openxmlformats.org/officeDocument/2006/relationships" id="268" r:id="R463964b2a31f41a4"/>
-    <p:sldId xmlns:r="http://schemas.openxmlformats.org/officeDocument/2006/relationships" id="269" r:id="Reca11802c3f74514"/>
-    <p:sldId xmlns:r="http://schemas.openxmlformats.org/officeDocument/2006/relationships" id="270" r:id="Red53f2b9dc7f418a"/>
+    <p:sldId xmlns:r="http://schemas.openxmlformats.org/officeDocument/2006/relationships" id="256" r:id="R11810af3c9bb4b39"/>
+    <p:sldId xmlns:r="http://schemas.openxmlformats.org/officeDocument/2006/relationships" id="257" r:id="R69ef675a25494a95"/>
+    <p:sldId xmlns:r="http://schemas.openxmlformats.org/officeDocument/2006/relationships" id="258" r:id="R217524976482488c"/>
+    <p:sldId xmlns:r="http://schemas.openxmlformats.org/officeDocument/2006/relationships" id="259" r:id="Ra6680a78f7384a46"/>
+    <p:sldId xmlns:r="http://schemas.openxmlformats.org/officeDocument/2006/relationships" id="260" r:id="R41950f779c48416d"/>
+    <p:sldId xmlns:r="http://schemas.openxmlformats.org/officeDocument/2006/relationships" id="261" r:id="Rb7bd63e8fe23470f"/>
+    <p:sldId xmlns:r="http://schemas.openxmlformats.org/officeDocument/2006/relationships" id="262" r:id="R08925b3e1d2a4076"/>
+    <p:sldId xmlns:r="http://schemas.openxmlformats.org/officeDocument/2006/relationships" id="263" r:id="R6440229f1a954835"/>
+    <p:sldId xmlns:r="http://schemas.openxmlformats.org/officeDocument/2006/relationships" id="264" r:id="R0c1cbee90acb45d0"/>
+    <p:sldId xmlns:r="http://schemas.openxmlformats.org/officeDocument/2006/relationships" id="265" r:id="Ref3ac02e2626408b"/>
+    <p:sldId xmlns:r="http://schemas.openxmlformats.org/officeDocument/2006/relationships" id="266" r:id="Ra79e74ec10864d3f"/>
+    <p:sldId xmlns:r="http://schemas.openxmlformats.org/officeDocument/2006/relationships" id="267" r:id="Redc2ec8c8b3e417e"/>
+    <p:sldId xmlns:r="http://schemas.openxmlformats.org/officeDocument/2006/relationships" id="268" r:id="Rf0313a3cddbb46df"/>
+    <p:sldId xmlns:r="http://schemas.openxmlformats.org/officeDocument/2006/relationships" id="269" r:id="R94e7fdff3c94498c"/>
+    <p:sldId xmlns:r="http://schemas.openxmlformats.org/officeDocument/2006/relationships" id="270" r:id="R2909b80aa9c84189"/>
   </p:sldIdLst>
   <p:sldSz cx="12192000" cy="6858000"/>
   <p:notesSz cx="6858000" cy="9144000"/>
@@ -481,7 +481,7 @@
           </a:p>
           <a:p xmlns:a="http://schemas.openxmlformats.org/drawingml/2006/main">
             <a:r>
-              <a:t>https://github.com/PracticasProfesionalizantes-I-2026/Grupo-9-TurnosLavadero/blob/cierre-entrega-y-demo/README.md</a:t>
+              <a:t>https://github.com/PracticasProfesionalizantes-I-2026/Grupo-9-TurnosLavadero/blob/demo-completamente-csharp/README.md</a:t>
             </a:r>
           </a:p>
         </p:txBody>
@@ -576,12 +576,12 @@
           </a:p>
           <a:p xmlns:a="http://schemas.openxmlformats.org/drawingml/2006/main">
             <a:r>
-              <a:t>https://github.com/PracticasProfesionalizantes-I-2026/Grupo-9-TurnosLavadero/blob/cierre-entrega-y-demo/Documentos/Entregas%20TP/REQUISITOS.md</a:t>
-            </a:r>
-          </a:p>
-          <a:p xmlns:a="http://schemas.openxmlformats.org/drawingml/2006/main">
-            <a:r>
-              <a:t>https://github.com/PracticasProfesionalizantes-I-2026/Grupo-9-TurnosLavadero/blob/cierre-entrega-y-demo/BusinessLogic/Services/TurnoService.cs</a:t>
+              <a:t>https://github.com/PracticasProfesionalizantes-I-2026/Grupo-9-TurnosLavadero/blob/demo-completamente-csharp/Documentos/Entregas%20TP/REQUISITOS.md</a:t>
+            </a:r>
+          </a:p>
+          <a:p xmlns:a="http://schemas.openxmlformats.org/drawingml/2006/main">
+            <a:r>
+              <a:t>https://github.com/PracticasProfesionalizantes-I-2026/Grupo-9-TurnosLavadero/blob/demo-completamente-csharp/BusinessLogic/Services/TurnoService.cs</a:t>
             </a:r>
           </a:p>
         </p:txBody>
@@ -676,12 +676,12 @@
           </a:p>
           <a:p xmlns:a="http://schemas.openxmlformats.org/drawingml/2006/main">
             <a:r>
-              <a:t>https://github.com/PracticasProfesionalizantes-I-2026/Grupo-9-TurnosLavadero/blob/cierre-entrega-y-demo/Documentos/Entregas%20TP/REQUISITOS.md</a:t>
-            </a:r>
-          </a:p>
-          <a:p xmlns:a="http://schemas.openxmlformats.org/drawingml/2006/main">
-            <a:r>
-              <a:t>https://github.com/PracticasProfesionalizantes-I-2026/Grupo-9-TurnosLavadero/blob/cierre-entrega-y-demo/BusinessLogic/Services/TurnoService.cs</a:t>
+              <a:t>https://github.com/PracticasProfesionalizantes-I-2026/Grupo-9-TurnosLavadero/blob/demo-completamente-csharp/Documentos/Entregas%20TP/REQUISITOS.md</a:t>
+            </a:r>
+          </a:p>
+          <a:p xmlns:a="http://schemas.openxmlformats.org/drawingml/2006/main">
+            <a:r>
+              <a:t>https://github.com/PracticasProfesionalizantes-I-2026/Grupo-9-TurnosLavadero/blob/demo-completamente-csharp/BusinessLogic/Services/TurnoService.cs</a:t>
             </a:r>
           </a:p>
         </p:txBody>
@@ -776,12 +776,12 @@
           </a:p>
           <a:p xmlns:a="http://schemas.openxmlformats.org/drawingml/2006/main">
             <a:r>
-              <a:t>https://github.com/PracticasProfesionalizantes-I-2026/Grupo-9-TurnosLavadero/blob/cierre-entrega-y-demo/Documentos/Entregas%20TP/REQUISITOS.md</a:t>
-            </a:r>
-          </a:p>
-          <a:p xmlns:a="http://schemas.openxmlformats.org/drawingml/2006/main">
-            <a:r>
-              <a:t>https://github.com/PracticasProfesionalizantes-I-2026/Grupo-9-TurnosLavadero/blob/cierre-entrega-y-demo/BusinessLogic/Services/ServicioService.cs</a:t>
+              <a:t>https://github.com/PracticasProfesionalizantes-I-2026/Grupo-9-TurnosLavadero/blob/demo-completamente-csharp/Documentos/Entregas%20TP/REQUISITOS.md</a:t>
+            </a:r>
+          </a:p>
+          <a:p xmlns:a="http://schemas.openxmlformats.org/drawingml/2006/main">
+            <a:r>
+              <a:t>https://github.com/PracticasProfesionalizantes-I-2026/Grupo-9-TurnosLavadero/blob/demo-completamente-csharp/BusinessLogic/Services/ServicioService.cs</a:t>
             </a:r>
           </a:p>
         </p:txBody>
@@ -876,22 +876,22 @@
           </a:p>
           <a:p xmlns:a="http://schemas.openxmlformats.org/drawingml/2006/main">
             <a:r>
-              <a:t>https://github.com/PracticasProfesionalizantes-I-2026/Grupo-9-TurnosLavadero/blob/cierre-entrega-y-demo/BusinessLogic/Services/RecordatorioProcessor.cs</a:t>
-            </a:r>
-          </a:p>
-          <a:p xmlns:a="http://schemas.openxmlformats.org/drawingml/2006/main">
-            <a:r>
-              <a:t>https://github.com/PracticasProfesionalizantes-I-2026/Grupo-9-TurnosLavadero/blob/cierre-entrega-y-demo/API/Notifications/RecordatorioWorker.cs</a:t>
-            </a:r>
-          </a:p>
-          <a:p xmlns:a="http://schemas.openxmlformats.org/drawingml/2006/main">
-            <a:r>
-              <a:t>https://github.com/PracticasProfesionalizantes-I-2026/Grupo-9-TurnosLavadero/blob/cierre-entrega-y-demo/scripts/demo.py</a:t>
-            </a:r>
-          </a:p>
-          <a:p xmlns:a="http://schemas.openxmlformats.org/drawingml/2006/main">
-            <a:r>
-              <a:t>https://github.com/PracticasProfesionalizantes-I-2026/Grupo-9-TurnosLavadero/blob/cierre-entrega-y-demo/Documentos/RECORDATORIOS.md</a:t>
+              <a:t>https://github.com/PracticasProfesionalizantes-I-2026/Grupo-9-TurnosLavadero/blob/demo-completamente-csharp/BusinessLogic/Services/RecordatorioProcessor.cs</a:t>
+            </a:r>
+          </a:p>
+          <a:p xmlns:a="http://schemas.openxmlformats.org/drawingml/2006/main">
+            <a:r>
+              <a:t>https://github.com/PracticasProfesionalizantes-I-2026/Grupo-9-TurnosLavadero/blob/demo-completamente-csharp/API/Notifications/RecordatorioWorker.cs</a:t>
+            </a:r>
+          </a:p>
+          <a:p xmlns:a="http://schemas.openxmlformats.org/drawingml/2006/main">
+            <a:r>
+              <a:t>https://github.com/PracticasProfesionalizantes-I-2026/Grupo-9-TurnosLavadero/blob/demo-completamente-csharp/tools/DemoRunner/Program.cs</a:t>
+            </a:r>
+          </a:p>
+          <a:p xmlns:a="http://schemas.openxmlformats.org/drawingml/2006/main">
+            <a:r>
+              <a:t>https://github.com/PracticasProfesionalizantes-I-2026/Grupo-9-TurnosLavadero/blob/demo-completamente-csharp/Documentos/RECORDATORIOS.md</a:t>
             </a:r>
           </a:p>
         </p:txBody>
@@ -971,7 +971,7 @@
           </a:p>
           <a:p xmlns:a="http://schemas.openxmlformats.org/drawingml/2006/main">
             <a:r>
-              <a:t>Juan: mostrar dotnet build y dotnet test o el resultado de GitHub Actions, indicando si alguna comprobación sigue pendiente. Tomás: abrir demo.html generado por scripts/demo.py. Mostrar códigos y el correo capturado. La colección Bruno sirve para la demostración en vivo, la suite automática para reproducir los escenarios. No inventar una cantidad de pruebas aprobadas.</a:t>
+              <a:t>Juan: mostrar dotnet build y dotnet test o el resultado de GitHub Actions, indicando si alguna comprobación sigue pendiente. Tomás: abrir demo.html generado por tools/DemoRunner/Program.cs. Mostrar códigos y el correo capturado. La colección Bruno sirve para la demostración en vivo, la suite automática para reproducir los escenarios. No inventar una cantidad de pruebas aprobadas.</a:t>
             </a:r>
           </a:p>
           <a:p xmlns:a="http://schemas.openxmlformats.org/drawingml/2006/main">
@@ -986,22 +986,22 @@
           </a:p>
           <a:p xmlns:a="http://schemas.openxmlformats.org/drawingml/2006/main">
             <a:r>
-              <a:t>https://github.com/PracticasProfesionalizantes-I-2026/Grupo-9-TurnosLavadero/blob/cierre-entrega-y-demo/Tests/IntegrationTests/AgendaAndConcurrencyTests.cs</a:t>
-            </a:r>
-          </a:p>
-          <a:p xmlns:a="http://schemas.openxmlformats.org/drawingml/2006/main">
-            <a:r>
-              <a:t>https://github.com/PracticasProfesionalizantes-I-2026/Grupo-9-TurnosLavadero/blob/cierre-entrega-y-demo/Documentos/Entregas%20TP/TRAZABILIDAD.md</a:t>
-            </a:r>
-          </a:p>
-          <a:p xmlns:a="http://schemas.openxmlformats.org/drawingml/2006/main">
-            <a:r>
-              <a:t>https://github.com/PracticasProfesionalizantes-I-2026/Grupo-9-TurnosLavadero/blob/cierre-entrega-y-demo/.github/workflows/verificar.yml</a:t>
-            </a:r>
-          </a:p>
-          <a:p xmlns:a="http://schemas.openxmlformats.org/drawingml/2006/main">
-            <a:r>
-              <a:t>https://github.com/PracticasProfesionalizantes-I-2026/Grupo-9-TurnosLavadero/blob/cierre-entrega-y-demo/scripts/demo.py</a:t>
+              <a:t>https://github.com/PracticasProfesionalizantes-I-2026/Grupo-9-TurnosLavadero/blob/demo-completamente-csharp/Tests/IntegrationTests/AgendaAndConcurrencyTests.cs</a:t>
+            </a:r>
+          </a:p>
+          <a:p xmlns:a="http://schemas.openxmlformats.org/drawingml/2006/main">
+            <a:r>
+              <a:t>https://github.com/PracticasProfesionalizantes-I-2026/Grupo-9-TurnosLavadero/blob/demo-completamente-csharp/Documentos/Entregas%20TP/TRAZABILIDAD.md</a:t>
+            </a:r>
+          </a:p>
+          <a:p xmlns:a="http://schemas.openxmlformats.org/drawingml/2006/main">
+            <a:r>
+              <a:t>https://github.com/PracticasProfesionalizantes-I-2026/Grupo-9-TurnosLavadero/blob/demo-completamente-csharp/.github/workflows/verificar.yml</a:t>
+            </a:r>
+          </a:p>
+          <a:p xmlns:a="http://schemas.openxmlformats.org/drawingml/2006/main">
+            <a:r>
+              <a:t>https://github.com/PracticasProfesionalizantes-I-2026/Grupo-9-TurnosLavadero/blob/demo-completamente-csharp/tools/DemoRunner/Program.cs</a:t>
             </a:r>
           </a:p>
         </p:txBody>
@@ -1096,12 +1096,12 @@
           </a:p>
           <a:p xmlns:a="http://schemas.openxmlformats.org/drawingml/2006/main">
             <a:r>
-              <a:t>https://github.com/PracticasProfesionalizantes-I-2026/Grupo-9-TurnosLavadero/blob/cierre-entrega-y-demo/Documentos/Entregas%20TP/Alcance%20del%20Sistema.md</a:t>
-            </a:r>
-          </a:p>
-          <a:p xmlns:a="http://schemas.openxmlformats.org/drawingml/2006/main">
-            <a:r>
-              <a:t>https://github.com/PracticasProfesionalizantes-I-2026/Grupo-9-TurnosLavadero/blob/cierre-entrega-y-demo/Documentos/Presentacion/REVISION-Y-ENTREGA.md</a:t>
+              <a:t>https://github.com/PracticasProfesionalizantes-I-2026/Grupo-9-TurnosLavadero/blob/demo-completamente-csharp/Documentos/Entregas%20TP/Alcance%20del%20Sistema.md</a:t>
+            </a:r>
+          </a:p>
+          <a:p xmlns:a="http://schemas.openxmlformats.org/drawingml/2006/main">
+            <a:r>
+              <a:t>https://github.com/PracticasProfesionalizantes-I-2026/Grupo-9-TurnosLavadero/blob/demo-completamente-csharp/Documentos/Presentacion/REVISION-Y-ENTREGA.md</a:t>
             </a:r>
           </a:p>
         </p:txBody>
@@ -1196,7 +1196,7 @@
           </a:p>
           <a:p xmlns:a="http://schemas.openxmlformats.org/drawingml/2006/main">
             <a:r>
-              <a:t>https://github.com/PracticasProfesionalizantes-I-2026/Grupo-9-TurnosLavadero/blob/cierre-entrega-y-demo/Documentos/Entregas%20TP/Alcance%20del%20Sistema.md</a:t>
+              <a:t>https://github.com/PracticasProfesionalizantes-I-2026/Grupo-9-TurnosLavadero/blob/demo-completamente-csharp/Documentos/Entregas%20TP/Alcance%20del%20Sistema.md</a:t>
             </a:r>
           </a:p>
         </p:txBody>
@@ -1291,12 +1291,12 @@
           </a:p>
           <a:p xmlns:a="http://schemas.openxmlformats.org/drawingml/2006/main">
             <a:r>
-              <a:t>https://github.com/PracticasProfesionalizantes-I-2026/Grupo-9-TurnosLavadero/blob/cierre-entrega-y-demo/Documentos/Entregas%20TP/Alcance%20del%20Sistema.md</a:t>
-            </a:r>
-          </a:p>
-          <a:p xmlns:a="http://schemas.openxmlformats.org/drawingml/2006/main">
-            <a:r>
-              <a:t>https://github.com/PracticasProfesionalizantes-I-2026/Grupo-9-TurnosLavadero/blob/cierre-entrega-y-demo/BusinessLogic/Services/TurnoService.cs</a:t>
+              <a:t>https://github.com/PracticasProfesionalizantes-I-2026/Grupo-9-TurnosLavadero/blob/demo-completamente-csharp/Documentos/Entregas%20TP/Alcance%20del%20Sistema.md</a:t>
+            </a:r>
+          </a:p>
+          <a:p xmlns:a="http://schemas.openxmlformats.org/drawingml/2006/main">
+            <a:r>
+              <a:t>https://github.com/PracticasProfesionalizantes-I-2026/Grupo-9-TurnosLavadero/blob/demo-completamente-csharp/BusinessLogic/Services/TurnoService.cs</a:t>
             </a:r>
           </a:p>
         </p:txBody>
@@ -1391,12 +1391,12 @@
           </a:p>
           <a:p xmlns:a="http://schemas.openxmlformats.org/drawingml/2006/main">
             <a:r>
-              <a:t>https://github.com/PracticasProfesionalizantes-I-2026/Grupo-9-TurnosLavadero/blob/cierre-entrega-y-demo/DataAccess/Context/LavaderoDbContext.cs</a:t>
-            </a:r>
-          </a:p>
-          <a:p xmlns:a="http://schemas.openxmlformats.org/drawingml/2006/main">
-            <a:r>
-              <a:t>https://github.com/PracticasProfesionalizantes-I-2026/Grupo-9-TurnosLavadero/blob/cierre-entrega-y-demo/PLAN-ARQUITECTURA.md</a:t>
+              <a:t>https://github.com/PracticasProfesionalizantes-I-2026/Grupo-9-TurnosLavadero/blob/demo-completamente-csharp/DataAccess/Context/LavaderoDbContext.cs</a:t>
+            </a:r>
+          </a:p>
+          <a:p xmlns:a="http://schemas.openxmlformats.org/drawingml/2006/main">
+            <a:r>
+              <a:t>https://github.com/PracticasProfesionalizantes-I-2026/Grupo-9-TurnosLavadero/blob/demo-completamente-csharp/PLAN-ARQUITECTURA.md</a:t>
             </a:r>
           </a:p>
         </p:txBody>
@@ -1491,12 +1491,12 @@
           </a:p>
           <a:p xmlns:a="http://schemas.openxmlformats.org/drawingml/2006/main">
             <a:r>
-              <a:t>https://github.com/PracticasProfesionalizantes-I-2026/Grupo-9-TurnosLavadero/blob/cierre-entrega-y-demo/Documentos/Entregas%20TP/REQUISITOS.md</a:t>
-            </a:r>
-          </a:p>
-          <a:p xmlns:a="http://schemas.openxmlformats.org/drawingml/2006/main">
-            <a:r>
-              <a:t>https://github.com/PracticasProfesionalizantes-I-2026/Grupo-9-TurnosLavadero/blob/cierre-entrega-y-demo/Documentos/Entregas%20TP/TRAZABILIDAD.md</a:t>
+              <a:t>https://github.com/PracticasProfesionalizantes-I-2026/Grupo-9-TurnosLavadero/blob/demo-completamente-csharp/Documentos/Entregas%20TP/REQUISITOS.md</a:t>
+            </a:r>
+          </a:p>
+          <a:p xmlns:a="http://schemas.openxmlformats.org/drawingml/2006/main">
+            <a:r>
+              <a:t>https://github.com/PracticasProfesionalizantes-I-2026/Grupo-9-TurnosLavadero/blob/demo-completamente-csharp/Documentos/Entregas%20TP/TRAZABILIDAD.md</a:t>
             </a:r>
           </a:p>
         </p:txBody>
@@ -1591,17 +1591,17 @@
           </a:p>
           <a:p xmlns:a="http://schemas.openxmlformats.org/drawingml/2006/main">
             <a:r>
-              <a:t>https://github.com/PracticasProfesionalizantes-I-2026/Grupo-9-TurnosLavadero/blob/cierre-entrega-y-demo/Documentos/Entregas%20TP/REQUISITOS.md</a:t>
-            </a:r>
-          </a:p>
-          <a:p xmlns:a="http://schemas.openxmlformats.org/drawingml/2006/main">
-            <a:r>
-              <a:t>https://github.com/PracticasProfesionalizantes-I-2026/Grupo-9-TurnosLavadero/blob/cierre-entrega-y-demo/API/Security/PasswordService.cs</a:t>
-            </a:r>
-          </a:p>
-          <a:p xmlns:a="http://schemas.openxmlformats.org/drawingml/2006/main">
-            <a:r>
-              <a:t>https://github.com/PracticasProfesionalizantes-I-2026/Grupo-9-TurnosLavadero/blob/cierre-entrega-y-demo/DataAccess/Context/LavaderoDbContext.cs</a:t>
+              <a:t>https://github.com/PracticasProfesionalizantes-I-2026/Grupo-9-TurnosLavadero/blob/demo-completamente-csharp/Documentos/Entregas%20TP/REQUISITOS.md</a:t>
+            </a:r>
+          </a:p>
+          <a:p xmlns:a="http://schemas.openxmlformats.org/drawingml/2006/main">
+            <a:r>
+              <a:t>https://github.com/PracticasProfesionalizantes-I-2026/Grupo-9-TurnosLavadero/blob/demo-completamente-csharp/API/Security/PasswordService.cs</a:t>
+            </a:r>
+          </a:p>
+          <a:p xmlns:a="http://schemas.openxmlformats.org/drawingml/2006/main">
+            <a:r>
+              <a:t>https://github.com/PracticasProfesionalizantes-I-2026/Grupo-9-TurnosLavadero/blob/demo-completamente-csharp/DataAccess/Context/LavaderoDbContext.cs</a:t>
             </a:r>
           </a:p>
         </p:txBody>
@@ -1696,17 +1696,17 @@
           </a:p>
           <a:p xmlns:a="http://schemas.openxmlformats.org/drawingml/2006/main">
             <a:r>
-              <a:t>https://github.com/PracticasProfesionalizantes-I-2026/Grupo-9-TurnosLavadero/blob/cierre-entrega-y-demo/API/Controllers/TurnosController.cs</a:t>
-            </a:r>
-          </a:p>
-          <a:p xmlns:a="http://schemas.openxmlformats.org/drawingml/2006/main">
-            <a:r>
-              <a:t>https://github.com/PracticasProfesionalizantes-I-2026/Grupo-9-TurnosLavadero/blob/cierre-entrega-y-demo/BusinessLogic/Services/TurnoService.cs</a:t>
-            </a:r>
-          </a:p>
-          <a:p xmlns:a="http://schemas.openxmlformats.org/drawingml/2006/main">
-            <a:r>
-              <a:t>https://github.com/PracticasProfesionalizantes-I-2026/Grupo-9-TurnosLavadero/blob/cierre-entrega-y-demo/DataAccess/Repositories/TurnoRepository.cs</a:t>
+              <a:t>https://github.com/PracticasProfesionalizantes-I-2026/Grupo-9-TurnosLavadero/blob/demo-completamente-csharp/API/Controllers/TurnosController.cs</a:t>
+            </a:r>
+          </a:p>
+          <a:p xmlns:a="http://schemas.openxmlformats.org/drawingml/2006/main">
+            <a:r>
+              <a:t>https://github.com/PracticasProfesionalizantes-I-2026/Grupo-9-TurnosLavadero/blob/demo-completamente-csharp/BusinessLogic/Services/TurnoService.cs</a:t>
+            </a:r>
+          </a:p>
+          <a:p xmlns:a="http://schemas.openxmlformats.org/drawingml/2006/main">
+            <a:r>
+              <a:t>https://github.com/PracticasProfesionalizantes-I-2026/Grupo-9-TurnosLavadero/blob/demo-completamente-csharp/DataAccess/Repositories/TurnoRepository.cs</a:t>
             </a:r>
           </a:p>
         </p:txBody>
@@ -1801,12 +1801,12 @@
           </a:p>
           <a:p xmlns:a="http://schemas.openxmlformats.org/drawingml/2006/main">
             <a:r>
-              <a:t>https://github.com/PracticasProfesionalizantes-I-2026/Grupo-9-TurnosLavadero/blob/cierre-entrega-y-demo/Documentos/Entregas%20TP/REQUISITOS.md</a:t>
-            </a:r>
-          </a:p>
-          <a:p xmlns:a="http://schemas.openxmlformats.org/drawingml/2006/main">
-            <a:r>
-              <a:t>https://github.com/PracticasProfesionalizantes-I-2026/Grupo-9-TurnosLavadero/blob/cierre-entrega-y-demo/BusinessLogic/Services/AuthService.cs</a:t>
+              <a:t>https://github.com/PracticasProfesionalizantes-I-2026/Grupo-9-TurnosLavadero/blob/demo-completamente-csharp/Documentos/Entregas%20TP/REQUISITOS.md</a:t>
+            </a:r>
+          </a:p>
+          <a:p xmlns:a="http://schemas.openxmlformats.org/drawingml/2006/main">
+            <a:r>
+              <a:t>https://github.com/PracticasProfesionalizantes-I-2026/Grupo-9-TurnosLavadero/blob/demo-completamente-csharp/BusinessLogic/Services/AuthService.cs</a:t>
             </a:r>
           </a:p>
         </p:txBody>
@@ -1901,12 +1901,12 @@
           </a:p>
           <a:p xmlns:a="http://schemas.openxmlformats.org/drawingml/2006/main">
             <a:r>
-              <a:t>https://github.com/PracticasProfesionalizantes-I-2026/Grupo-9-TurnosLavadero/blob/cierre-entrega-y-demo/Documentos/Entregas%20TP/REQUISITOS.md</a:t>
-            </a:r>
-          </a:p>
-          <a:p xmlns:a="http://schemas.openxmlformats.org/drawingml/2006/main">
-            <a:r>
-              <a:t>https://github.com/PracticasProfesionalizantes-I-2026/Grupo-9-TurnosLavadero/blob/cierre-entrega-y-demo/BusinessLogic/Services/TurnoService.cs</a:t>
+              <a:t>https://github.com/PracticasProfesionalizantes-I-2026/Grupo-9-TurnosLavadero/blob/demo-completamente-csharp/Documentos/Entregas%20TP/REQUISITOS.md</a:t>
+            </a:r>
+          </a:p>
+          <a:p xmlns:a="http://schemas.openxmlformats.org/drawingml/2006/main">
+            <a:r>
+              <a:t>https://github.com/PracticasProfesionalizantes-I-2026/Grupo-9-TurnosLavadero/blob/demo-completamente-csharp/BusinessLogic/Services/TurnoService.cs</a:t>
             </a:r>
           </a:p>
         </p:txBody>
@@ -1953,7 +1953,7 @@
           <p:cNvPr id="3" name="Title">
             <a:extLst xmlns:a="http://schemas.openxmlformats.org/drawingml/2006/main">
               <a:ext uri="{FF2B5EF4-FFF2-40B4-BE49-F238E27FC236}">
-                <a16:creationId xmlns:a16="http://schemas.microsoft.com/office/drawing/2014/main" id="{1E79E33E-3FDA-4260-B581-B8B8FD95C0E2}"/>
+                <a16:creationId xmlns:a16="http://schemas.microsoft.com/office/drawing/2014/main" id="{91D371CF-0176-42EE-89D9-BBDB1F120339}"/>
               </a:ext>
             </a:extLst>
           </p:cNvPr>
@@ -2110,7 +2110,7 @@
           <p:cNvPr id="2" name="Subtitle">
             <a:extLst xmlns:a="http://schemas.openxmlformats.org/drawingml/2006/main">
               <a:ext uri="{FF2B5EF4-FFF2-40B4-BE49-F238E27FC236}">
-                <a16:creationId xmlns:a16="http://schemas.microsoft.com/office/drawing/2014/main" id="{EC7009BE-C536-4BDA-86D4-AB8E9D625E71}"/>
+                <a16:creationId xmlns:a16="http://schemas.microsoft.com/office/drawing/2014/main" id="{F835E424-FB9F-4DA6-98B6-C19AF89721D4}"/>
               </a:ext>
             </a:extLst>
           </p:cNvPr>
@@ -2284,7 +2284,7 @@
           <p:cNvPr id="2" name="Section title">
             <a:extLst xmlns:a="http://schemas.openxmlformats.org/drawingml/2006/main">
               <a:ext uri="{FF2B5EF4-FFF2-40B4-BE49-F238E27FC236}">
-                <a16:creationId xmlns:a16="http://schemas.microsoft.com/office/drawing/2014/main" id="{2A8AB527-A084-47FD-B886-A560C8F1B274}"/>
+                <a16:creationId xmlns:a16="http://schemas.microsoft.com/office/drawing/2014/main" id="{23471D96-C737-4C4B-AA4F-F1EA9FD1BF4A}"/>
               </a:ext>
             </a:extLst>
           </p:cNvPr>
@@ -2458,7 +2458,7 @@
           <p:cNvPr id="3" name="Title">
             <a:extLst xmlns:a="http://schemas.openxmlformats.org/drawingml/2006/main">
               <a:ext uri="{FF2B5EF4-FFF2-40B4-BE49-F238E27FC236}">
-                <a16:creationId xmlns:a16="http://schemas.microsoft.com/office/drawing/2014/main" id="{5E547C6E-7A44-49BB-B200-03296B88163C}"/>
+                <a16:creationId xmlns:a16="http://schemas.microsoft.com/office/drawing/2014/main" id="{9FA18F2B-4062-4365-95BA-2BFFF3FEDE50}"/>
               </a:ext>
             </a:extLst>
           </p:cNvPr>
@@ -2615,7 +2615,7 @@
           <p:cNvPr id="2" name="Body">
             <a:extLst xmlns:a="http://schemas.openxmlformats.org/drawingml/2006/main">
               <a:ext uri="{FF2B5EF4-FFF2-40B4-BE49-F238E27FC236}">
-                <a16:creationId xmlns:a16="http://schemas.microsoft.com/office/drawing/2014/main" id="{422E5F7B-EF80-4291-ADAB-F18527B00ECE}"/>
+                <a16:creationId xmlns:a16="http://schemas.microsoft.com/office/drawing/2014/main" id="{80742A6F-1C9E-40CB-9C2B-69DA08A814A9}"/>
               </a:ext>
             </a:extLst>
           </p:cNvPr>
@@ -2789,7 +2789,7 @@
           <p:cNvPr id="4" name="Title">
             <a:extLst xmlns:a="http://schemas.openxmlformats.org/drawingml/2006/main">
               <a:ext uri="{FF2B5EF4-FFF2-40B4-BE49-F238E27FC236}">
-                <a16:creationId xmlns:a16="http://schemas.microsoft.com/office/drawing/2014/main" id="{EF087754-596F-4389-B6EF-8107D0835C55}"/>
+                <a16:creationId xmlns:a16="http://schemas.microsoft.com/office/drawing/2014/main" id="{D7705FB0-0CC8-413A-A88F-EE9AAC34C8EF}"/>
               </a:ext>
             </a:extLst>
           </p:cNvPr>
@@ -2946,7 +2946,7 @@
           <p:cNvPr id="2" name="Left column">
             <a:extLst xmlns:a="http://schemas.openxmlformats.org/drawingml/2006/main">
               <a:ext uri="{FF2B5EF4-FFF2-40B4-BE49-F238E27FC236}">
-                <a16:creationId xmlns:a16="http://schemas.microsoft.com/office/drawing/2014/main" id="{4F1C6A4D-1495-45C6-9291-5623C64C41CB}"/>
+                <a16:creationId xmlns:a16="http://schemas.microsoft.com/office/drawing/2014/main" id="{832CEB03-005C-4761-910E-4FB468117DEB}"/>
               </a:ext>
             </a:extLst>
           </p:cNvPr>
@@ -3103,7 +3103,7 @@
           <p:cNvPr id="3" name="Right column">
             <a:extLst xmlns:a="http://schemas.openxmlformats.org/drawingml/2006/main">
               <a:ext uri="{FF2B5EF4-FFF2-40B4-BE49-F238E27FC236}">
-                <a16:creationId xmlns:a16="http://schemas.microsoft.com/office/drawing/2014/main" id="{1A301A58-A1F3-4B30-894B-F3399C11F665}"/>
+                <a16:creationId xmlns:a16="http://schemas.microsoft.com/office/drawing/2014/main" id="{5816E65D-985B-411D-A291-05133454E89D}"/>
               </a:ext>
             </a:extLst>
           </p:cNvPr>
@@ -3277,7 +3277,7 @@
           <p:cNvPr id="3" name="Title">
             <a:extLst xmlns:a="http://schemas.openxmlformats.org/drawingml/2006/main">
               <a:ext uri="{FF2B5EF4-FFF2-40B4-BE49-F238E27FC236}">
-                <a16:creationId xmlns:a16="http://schemas.microsoft.com/office/drawing/2014/main" id="{8884CE48-9468-4199-833D-392AF1F33D2B}"/>
+                <a16:creationId xmlns:a16="http://schemas.microsoft.com/office/drawing/2014/main" id="{AC32F698-0687-4114-BF88-B05DEA078016}"/>
               </a:ext>
             </a:extLst>
           </p:cNvPr>
@@ -3434,7 +3434,7 @@
           <p:cNvPr id="2" name="Left column">
             <a:extLst xmlns:a="http://schemas.openxmlformats.org/drawingml/2006/main">
               <a:ext uri="{FF2B5EF4-FFF2-40B4-BE49-F238E27FC236}">
-                <a16:creationId xmlns:a16="http://schemas.microsoft.com/office/drawing/2014/main" id="{B869CFDC-CF9E-4CAB-94B1-D9BDE878B5F3}"/>
+                <a16:creationId xmlns:a16="http://schemas.microsoft.com/office/drawing/2014/main" id="{EDB3C44C-457B-41AA-8814-DCEEB600AF6F}"/>
               </a:ext>
             </a:extLst>
           </p:cNvPr>
@@ -3629,12 +3629,12 @@
   </p:cSld>
   <p:clrMap bg1="lt1" tx1="dk1" bg2="lt2" tx2="dk2" accent1="accent1" accent2="accent2" accent3="accent3" accent4="accent4" accent5="accent5" accent6="accent6" hlink="hlink" folHlink="folHlink"/>
   <p:sldLayoutIdLst>
-    <p:sldLayoutId xmlns:r="http://schemas.openxmlformats.org/officeDocument/2006/relationships" id="2147483649" r:id="R4954c33f55c84e07"/>
-    <p:sldLayoutId xmlns:r="http://schemas.openxmlformats.org/officeDocument/2006/relationships" id="2147483650" r:id="Rffcf34c7486a4fd1"/>
-    <p:sldLayoutId xmlns:r="http://schemas.openxmlformats.org/officeDocument/2006/relationships" id="2147483651" r:id="R7ff76b10ce6247e8"/>
-    <p:sldLayoutId xmlns:r="http://schemas.openxmlformats.org/officeDocument/2006/relationships" id="2147483652" r:id="R588360c55fd143f9"/>
-    <p:sldLayoutId xmlns:r="http://schemas.openxmlformats.org/officeDocument/2006/relationships" id="2147483653" r:id="R2da4fbdc89df4cd1"/>
-    <p:sldLayoutId xmlns:r="http://schemas.openxmlformats.org/officeDocument/2006/relationships" id="2147483654" r:id="Re51ac3db9e244b8e"/>
+    <p:sldLayoutId xmlns:r="http://schemas.openxmlformats.org/officeDocument/2006/relationships" id="2147483649" r:id="R86ee67611ed54112"/>
+    <p:sldLayoutId xmlns:r="http://schemas.openxmlformats.org/officeDocument/2006/relationships" id="2147483650" r:id="R18042d705ec74d60"/>
+    <p:sldLayoutId xmlns:r="http://schemas.openxmlformats.org/officeDocument/2006/relationships" id="2147483651" r:id="R74464f9c32724802"/>
+    <p:sldLayoutId xmlns:r="http://schemas.openxmlformats.org/officeDocument/2006/relationships" id="2147483652" r:id="Ra23d875ce6774dd2"/>
+    <p:sldLayoutId xmlns:r="http://schemas.openxmlformats.org/officeDocument/2006/relationships" id="2147483653" r:id="R399d30e2b5354a76"/>
+    <p:sldLayoutId xmlns:r="http://schemas.openxmlformats.org/officeDocument/2006/relationships" id="2147483654" r:id="Rcd9df8a6f85f44db"/>
   </p:sldLayoutIdLst>
   <p:txStyles>
     <p:titleStyle>
@@ -4185,7 +4185,7 @@
           <p:cNvPr id="5" name="">
             <a:extLst xmlns:a="http://schemas.openxmlformats.org/drawingml/2006/main">
               <a:ext uri="{FF2B5EF4-FFF2-40B4-BE49-F238E27FC236}">
-                <a16:creationId xmlns:a16="http://schemas.microsoft.com/office/drawing/2014/main" id="{87E55EF6-FDD3-472B-92C0-2E3BEDCC14B6}"/>
+                <a16:creationId xmlns:a16="http://schemas.microsoft.com/office/drawing/2014/main" id="{2AD16031-7F00-4B1C-BFE0-EFB194C68ADF}"/>
               </a:ext>
             </a:extLst>
           </p:cNvPr>
@@ -4216,7 +4216,7 @@
           <p:cNvPr id="2" name="">
             <a:extLst xmlns:a="http://schemas.openxmlformats.org/drawingml/2006/main">
               <a:ext uri="{FF2B5EF4-FFF2-40B4-BE49-F238E27FC236}">
-                <a16:creationId xmlns:a16="http://schemas.microsoft.com/office/drawing/2014/main" id="{95807163-9409-4F54-8828-26276DAED7F5}"/>
+                <a16:creationId xmlns:a16="http://schemas.microsoft.com/office/drawing/2014/main" id="{32ACEB91-2474-4D14-97DC-F0E36BFD1D7A}"/>
               </a:ext>
             </a:extLst>
           </p:cNvPr>
@@ -4308,7 +4308,7 @@
           <p:cNvPr id="3" name="">
             <a:extLst xmlns:a="http://schemas.openxmlformats.org/drawingml/2006/main">
               <a:ext uri="{FF2B5EF4-FFF2-40B4-BE49-F238E27FC236}">
-                <a16:creationId xmlns:a16="http://schemas.microsoft.com/office/drawing/2014/main" id="{28B8B835-268E-4F0E-9CE3-985FB9128E12}"/>
+                <a16:creationId xmlns:a16="http://schemas.microsoft.com/office/drawing/2014/main" id="{6905A8C1-6F3C-415D-AAF5-EFA2C20D0F57}"/>
               </a:ext>
             </a:extLst>
           </p:cNvPr>
@@ -4400,7 +4400,7 @@
           <p:cNvPr id="4" name="">
             <a:extLst xmlns:a="http://schemas.openxmlformats.org/drawingml/2006/main">
               <a:ext uri="{FF2B5EF4-FFF2-40B4-BE49-F238E27FC236}">
-                <a16:creationId xmlns:a16="http://schemas.microsoft.com/office/drawing/2014/main" id="{9E3E0889-8C26-4EC4-BD97-A4102EC35139}"/>
+                <a16:creationId xmlns:a16="http://schemas.microsoft.com/office/drawing/2014/main" id="{336EC8A2-A5F8-41E5-9B6A-D31C5A789136}"/>
               </a:ext>
             </a:extLst>
           </p:cNvPr>
@@ -4467,7 +4467,7 @@
     </p:spTree>
     <p:extLst>
       <p:ext uri="{BB962C8B-B14F-4D97-AF65-F5344CB8AC3E}">
-        <p14:creationId xmlns:p14="http://schemas.microsoft.com/office/powerpoint/2010/main" val="1888371190"/>
+        <p14:creationId xmlns:p14="http://schemas.microsoft.com/office/powerpoint/2010/main" val="1399773191"/>
       </p:ext>
     </p:extLst>
   </p:cSld>
@@ -4498,7 +4498,7 @@
           <p:cNvPr id="14" name="">
             <a:extLst xmlns:a="http://schemas.openxmlformats.org/drawingml/2006/main">
               <a:ext uri="{FF2B5EF4-FFF2-40B4-BE49-F238E27FC236}">
-                <a16:creationId xmlns:a16="http://schemas.microsoft.com/office/drawing/2014/main" id="{8F545861-6FCF-4E0C-91F2-2EB71FE2D887}"/>
+                <a16:creationId xmlns:a16="http://schemas.microsoft.com/office/drawing/2014/main" id="{7BB680F4-7F6E-4FB8-A80D-A95CBD13FA55}"/>
               </a:ext>
             </a:extLst>
           </p:cNvPr>
@@ -4529,7 +4529,7 @@
           <p:cNvPr id="2" name="">
             <a:extLst xmlns:a="http://schemas.openxmlformats.org/drawingml/2006/main">
               <a:ext uri="{FF2B5EF4-FFF2-40B4-BE49-F238E27FC236}">
-                <a16:creationId xmlns:a16="http://schemas.microsoft.com/office/drawing/2014/main" id="{366F7927-A495-4AE5-82FD-A9C07C9C4323}"/>
+                <a16:creationId xmlns:a16="http://schemas.microsoft.com/office/drawing/2014/main" id="{9AD1B123-12E3-4E6C-8025-9A0DBB6B6076}"/>
               </a:ext>
             </a:extLst>
           </p:cNvPr>
@@ -4598,7 +4598,7 @@
           <p:cNvPr id="3" name="">
             <a:extLst xmlns:a="http://schemas.openxmlformats.org/drawingml/2006/main">
               <a:ext uri="{FF2B5EF4-FFF2-40B4-BE49-F238E27FC236}">
-                <a16:creationId xmlns:a16="http://schemas.microsoft.com/office/drawing/2014/main" id="{2083BB1B-66D2-4698-86B3-A1B7DA7A68E3}"/>
+                <a16:creationId xmlns:a16="http://schemas.microsoft.com/office/drawing/2014/main" id="{4F325FA2-2944-4024-B164-365EA19701CE}"/>
               </a:ext>
             </a:extLst>
           </p:cNvPr>
@@ -4629,7 +4629,7 @@
           <p:cNvPr id="4" name="">
             <a:extLst xmlns:a="http://schemas.openxmlformats.org/drawingml/2006/main">
               <a:ext uri="{FF2B5EF4-FFF2-40B4-BE49-F238E27FC236}">
-                <a16:creationId xmlns:a16="http://schemas.microsoft.com/office/drawing/2014/main" id="{7B86B2C0-CB78-41B1-BC6C-D512FDCB2380}"/>
+                <a16:creationId xmlns:a16="http://schemas.microsoft.com/office/drawing/2014/main" id="{5CF2AF6F-2C69-49BB-9C48-635BE27889D2}"/>
               </a:ext>
             </a:extLst>
           </p:cNvPr>
@@ -4698,7 +4698,7 @@
           <p:cNvPr id="5" name="">
             <a:extLst xmlns:a="http://schemas.openxmlformats.org/drawingml/2006/main">
               <a:ext uri="{FF2B5EF4-FFF2-40B4-BE49-F238E27FC236}">
-                <a16:creationId xmlns:a16="http://schemas.microsoft.com/office/drawing/2014/main" id="{52B4D700-118B-41A6-876C-2C44D0E1E8F9}"/>
+                <a16:creationId xmlns:a16="http://schemas.microsoft.com/office/drawing/2014/main" id="{E411E45E-EC81-4D41-BF93-F22D08B7F524}"/>
               </a:ext>
             </a:extLst>
           </p:cNvPr>
@@ -4767,7 +4767,7 @@
           <p:cNvPr id="6" name="">
             <a:extLst xmlns:a="http://schemas.openxmlformats.org/drawingml/2006/main">
               <a:ext uri="{FF2B5EF4-FFF2-40B4-BE49-F238E27FC236}">
-                <a16:creationId xmlns:a16="http://schemas.microsoft.com/office/drawing/2014/main" id="{27158AE6-0BFC-4A94-980A-5C08C848A1A4}"/>
+                <a16:creationId xmlns:a16="http://schemas.microsoft.com/office/drawing/2014/main" id="{0591CD45-900B-4997-8EE2-E18311F3F34F}"/>
               </a:ext>
             </a:extLst>
           </p:cNvPr>
@@ -4836,7 +4836,7 @@
           <p:cNvPr id="7" name="">
             <a:extLst xmlns:a="http://schemas.openxmlformats.org/drawingml/2006/main">
               <a:ext uri="{FF2B5EF4-FFF2-40B4-BE49-F238E27FC236}">
-                <a16:creationId xmlns:a16="http://schemas.microsoft.com/office/drawing/2014/main" id="{17994E33-DE60-414E-8F0E-4603A4806F4D}"/>
+                <a16:creationId xmlns:a16="http://schemas.microsoft.com/office/drawing/2014/main" id="{6EB4E66A-FC91-460F-8032-52BFC900B2B9}"/>
               </a:ext>
             </a:extLst>
           </p:cNvPr>
@@ -4928,7 +4928,7 @@
           <p:cNvPr id="8" name="">
             <a:extLst xmlns:a="http://schemas.openxmlformats.org/drawingml/2006/main">
               <a:ext uri="{FF2B5EF4-FFF2-40B4-BE49-F238E27FC236}">
-                <a16:creationId xmlns:a16="http://schemas.microsoft.com/office/drawing/2014/main" id="{6326D9FE-6F06-4995-968B-14498EDE69BA}"/>
+                <a16:creationId xmlns:a16="http://schemas.microsoft.com/office/drawing/2014/main" id="{2F71D24F-1C30-42CF-94AD-3B08B3D372AD}"/>
               </a:ext>
             </a:extLst>
           </p:cNvPr>
@@ -4997,7 +4997,7 @@
           <p:cNvPr id="9" name="">
             <a:extLst xmlns:a="http://schemas.openxmlformats.org/drawingml/2006/main">
               <a:ext uri="{FF2B5EF4-FFF2-40B4-BE49-F238E27FC236}">
-                <a16:creationId xmlns:a16="http://schemas.microsoft.com/office/drawing/2014/main" id="{2ABCE5F3-B26E-449D-92CC-2A4BD9F1C51E}"/>
+                <a16:creationId xmlns:a16="http://schemas.microsoft.com/office/drawing/2014/main" id="{65747678-78AD-4AEC-AA55-1D57D383447B}"/>
               </a:ext>
             </a:extLst>
           </p:cNvPr>
@@ -5066,7 +5066,7 @@
           <p:cNvPr id="10" name="">
             <a:extLst xmlns:a="http://schemas.openxmlformats.org/drawingml/2006/main">
               <a:ext uri="{FF2B5EF4-FFF2-40B4-BE49-F238E27FC236}">
-                <a16:creationId xmlns:a16="http://schemas.microsoft.com/office/drawing/2014/main" id="{A2288B57-86C8-43D1-9436-E98EFE5BB261}"/>
+                <a16:creationId xmlns:a16="http://schemas.microsoft.com/office/drawing/2014/main" id="{8F6CD1A6-275A-478B-9EBE-C8D6AB1142F0}"/>
               </a:ext>
             </a:extLst>
           </p:cNvPr>
@@ -5135,7 +5135,7 @@
           <p:cNvPr id="11" name="">
             <a:extLst xmlns:a="http://schemas.openxmlformats.org/drawingml/2006/main">
               <a:ext uri="{FF2B5EF4-FFF2-40B4-BE49-F238E27FC236}">
-                <a16:creationId xmlns:a16="http://schemas.microsoft.com/office/drawing/2014/main" id="{62D52920-F077-4A2D-B757-31B7B085172E}"/>
+                <a16:creationId xmlns:a16="http://schemas.microsoft.com/office/drawing/2014/main" id="{4BEAF0F0-70B9-4991-8CF2-4EF17CB70D02}"/>
               </a:ext>
             </a:extLst>
           </p:cNvPr>
@@ -5166,7 +5166,7 @@
           <p:cNvPr id="12" name="">
             <a:extLst xmlns:a="http://schemas.openxmlformats.org/drawingml/2006/main">
               <a:ext uri="{FF2B5EF4-FFF2-40B4-BE49-F238E27FC236}">
-                <a16:creationId xmlns:a16="http://schemas.microsoft.com/office/drawing/2014/main" id="{A8AFBEC5-F4C9-431E-AA7B-026422E0F5F2}"/>
+                <a16:creationId xmlns:a16="http://schemas.microsoft.com/office/drawing/2014/main" id="{1C5134CA-AF08-4143-A628-FE2EE22887AE}"/>
               </a:ext>
             </a:extLst>
           </p:cNvPr>
@@ -5332,7 +5332,7 @@
           <p:cNvPr id="13" name="">
             <a:extLst xmlns:a="http://schemas.openxmlformats.org/drawingml/2006/main">
               <a:ext uri="{FF2B5EF4-FFF2-40B4-BE49-F238E27FC236}">
-                <a16:creationId xmlns:a16="http://schemas.microsoft.com/office/drawing/2014/main" id="{B5A7BBBB-A553-4DBC-BB9E-4E215E266D01}"/>
+                <a16:creationId xmlns:a16="http://schemas.microsoft.com/office/drawing/2014/main" id="{4D76B0BA-412C-4FF8-95BA-C6DFC1EE4FD9}"/>
               </a:ext>
             </a:extLst>
           </p:cNvPr>
@@ -5399,7 +5399,7 @@
     </p:spTree>
     <p:extLst>
       <p:ext uri="{BB962C8B-B14F-4D97-AF65-F5344CB8AC3E}">
-        <p14:creationId xmlns:p14="http://schemas.microsoft.com/office/powerpoint/2010/main" val="1885555027"/>
+        <p14:creationId xmlns:p14="http://schemas.microsoft.com/office/powerpoint/2010/main" val="639210492"/>
       </p:ext>
     </p:extLst>
   </p:cSld>
@@ -5430,7 +5430,7 @@
           <p:cNvPr id="14" name="">
             <a:extLst xmlns:a="http://schemas.openxmlformats.org/drawingml/2006/main">
               <a:ext uri="{FF2B5EF4-FFF2-40B4-BE49-F238E27FC236}">
-                <a16:creationId xmlns:a16="http://schemas.microsoft.com/office/drawing/2014/main" id="{D7C1577D-E9C4-443E-BEE4-7D43D0741F4F}"/>
+                <a16:creationId xmlns:a16="http://schemas.microsoft.com/office/drawing/2014/main" id="{6BEE0F1A-31F3-44EB-8F49-B6318C188B63}"/>
               </a:ext>
             </a:extLst>
           </p:cNvPr>
@@ -5461,7 +5461,7 @@
           <p:cNvPr id="2" name="">
             <a:extLst xmlns:a="http://schemas.openxmlformats.org/drawingml/2006/main">
               <a:ext uri="{FF2B5EF4-FFF2-40B4-BE49-F238E27FC236}">
-                <a16:creationId xmlns:a16="http://schemas.microsoft.com/office/drawing/2014/main" id="{87B8BB61-932C-4648-946D-7E9AFCBB7DD1}"/>
+                <a16:creationId xmlns:a16="http://schemas.microsoft.com/office/drawing/2014/main" id="{C6B6A95A-EC7D-4A6A-800F-340B0977CB55}"/>
               </a:ext>
             </a:extLst>
           </p:cNvPr>
@@ -5530,7 +5530,7 @@
           <p:cNvPr id="3" name="">
             <a:extLst xmlns:a="http://schemas.openxmlformats.org/drawingml/2006/main">
               <a:ext uri="{FF2B5EF4-FFF2-40B4-BE49-F238E27FC236}">
-                <a16:creationId xmlns:a16="http://schemas.microsoft.com/office/drawing/2014/main" id="{294A5F80-E8DC-4154-89E3-75052AA533F6}"/>
+                <a16:creationId xmlns:a16="http://schemas.microsoft.com/office/drawing/2014/main" id="{935A8E78-2EB2-4B4B-8CB7-734EC9323144}"/>
               </a:ext>
             </a:extLst>
           </p:cNvPr>
@@ -5561,7 +5561,7 @@
           <p:cNvPr id="4" name="">
             <a:extLst xmlns:a="http://schemas.openxmlformats.org/drawingml/2006/main">
               <a:ext uri="{FF2B5EF4-FFF2-40B4-BE49-F238E27FC236}">
-                <a16:creationId xmlns:a16="http://schemas.microsoft.com/office/drawing/2014/main" id="{54D277CA-1F16-46D7-B872-EC9D793B2EAE}"/>
+                <a16:creationId xmlns:a16="http://schemas.microsoft.com/office/drawing/2014/main" id="{9F3F74BE-747D-40EA-A0A6-5DEB1B0A0C4F}"/>
               </a:ext>
             </a:extLst>
           </p:cNvPr>
@@ -5630,7 +5630,7 @@
           <p:cNvPr id="5" name="">
             <a:extLst xmlns:a="http://schemas.openxmlformats.org/drawingml/2006/main">
               <a:ext uri="{FF2B5EF4-FFF2-40B4-BE49-F238E27FC236}">
-                <a16:creationId xmlns:a16="http://schemas.microsoft.com/office/drawing/2014/main" id="{B3A729B0-1AB7-4E81-8277-E3A3C01D0AA6}"/>
+                <a16:creationId xmlns:a16="http://schemas.microsoft.com/office/drawing/2014/main" id="{12705954-7DB9-428D-B465-B1DEB0FE941E}"/>
               </a:ext>
             </a:extLst>
           </p:cNvPr>
@@ -5699,7 +5699,7 @@
           <p:cNvPr id="6" name="">
             <a:extLst xmlns:a="http://schemas.openxmlformats.org/drawingml/2006/main">
               <a:ext uri="{FF2B5EF4-FFF2-40B4-BE49-F238E27FC236}">
-                <a16:creationId xmlns:a16="http://schemas.microsoft.com/office/drawing/2014/main" id="{AC0F62E7-F5E0-4CD9-B217-6812AF473DBE}"/>
+                <a16:creationId xmlns:a16="http://schemas.microsoft.com/office/drawing/2014/main" id="{6CEEA19F-221A-427A-AD0C-18B8C2C69D84}"/>
               </a:ext>
             </a:extLst>
           </p:cNvPr>
@@ -5768,7 +5768,7 @@
           <p:cNvPr id="7" name="">
             <a:extLst xmlns:a="http://schemas.openxmlformats.org/drawingml/2006/main">
               <a:ext uri="{FF2B5EF4-FFF2-40B4-BE49-F238E27FC236}">
-                <a16:creationId xmlns:a16="http://schemas.microsoft.com/office/drawing/2014/main" id="{D324E7AF-26C2-4126-986B-DD673461F4A1}"/>
+                <a16:creationId xmlns:a16="http://schemas.microsoft.com/office/drawing/2014/main" id="{29CE6D7A-E087-42D8-B2C7-94272E4D2780}"/>
               </a:ext>
             </a:extLst>
           </p:cNvPr>
@@ -5860,7 +5860,7 @@
           <p:cNvPr id="8" name="">
             <a:extLst xmlns:a="http://schemas.openxmlformats.org/drawingml/2006/main">
               <a:ext uri="{FF2B5EF4-FFF2-40B4-BE49-F238E27FC236}">
-                <a16:creationId xmlns:a16="http://schemas.microsoft.com/office/drawing/2014/main" id="{0EEA964C-B36B-4C05-9C0E-B4EFC64FBB43}"/>
+                <a16:creationId xmlns:a16="http://schemas.microsoft.com/office/drawing/2014/main" id="{34E8A1B3-069D-46C3-9CAF-5E508A05A850}"/>
               </a:ext>
             </a:extLst>
           </p:cNvPr>
@@ -5929,7 +5929,7 @@
           <p:cNvPr id="9" name="">
             <a:extLst xmlns:a="http://schemas.openxmlformats.org/drawingml/2006/main">
               <a:ext uri="{FF2B5EF4-FFF2-40B4-BE49-F238E27FC236}">
-                <a16:creationId xmlns:a16="http://schemas.microsoft.com/office/drawing/2014/main" id="{A3811FB2-6C81-494B-B4CB-C1EBD9E75AF5}"/>
+                <a16:creationId xmlns:a16="http://schemas.microsoft.com/office/drawing/2014/main" id="{29843BE4-79A2-44EA-AFEF-042574407B32}"/>
               </a:ext>
             </a:extLst>
           </p:cNvPr>
@@ -5998,7 +5998,7 @@
           <p:cNvPr id="10" name="">
             <a:extLst xmlns:a="http://schemas.openxmlformats.org/drawingml/2006/main">
               <a:ext uri="{FF2B5EF4-FFF2-40B4-BE49-F238E27FC236}">
-                <a16:creationId xmlns:a16="http://schemas.microsoft.com/office/drawing/2014/main" id="{A3391E0E-4260-4F0E-B73F-D442EC266013}"/>
+                <a16:creationId xmlns:a16="http://schemas.microsoft.com/office/drawing/2014/main" id="{DD02D800-6E75-49B6-955A-EB50AE0AD3C1}"/>
               </a:ext>
             </a:extLst>
           </p:cNvPr>
@@ -6067,7 +6067,7 @@
           <p:cNvPr id="11" name="">
             <a:extLst xmlns:a="http://schemas.openxmlformats.org/drawingml/2006/main">
               <a:ext uri="{FF2B5EF4-FFF2-40B4-BE49-F238E27FC236}">
-                <a16:creationId xmlns:a16="http://schemas.microsoft.com/office/drawing/2014/main" id="{6736FCC8-A778-472C-90E1-7B341AB088A0}"/>
+                <a16:creationId xmlns:a16="http://schemas.microsoft.com/office/drawing/2014/main" id="{D7162F5F-E1EF-4855-8CEE-FBEE0A63ABDE}"/>
               </a:ext>
             </a:extLst>
           </p:cNvPr>
@@ -6098,7 +6098,7 @@
           <p:cNvPr id="12" name="">
             <a:extLst xmlns:a="http://schemas.openxmlformats.org/drawingml/2006/main">
               <a:ext uri="{FF2B5EF4-FFF2-40B4-BE49-F238E27FC236}">
-                <a16:creationId xmlns:a16="http://schemas.microsoft.com/office/drawing/2014/main" id="{4349B7BF-C58E-40A6-90B7-F580DBCB27F9}"/>
+                <a16:creationId xmlns:a16="http://schemas.microsoft.com/office/drawing/2014/main" id="{4E59E820-127E-4EF4-A661-5DCC726FD9EC}"/>
               </a:ext>
             </a:extLst>
           </p:cNvPr>
@@ -6246,7 +6246,7 @@
           <p:cNvPr id="13" name="">
             <a:extLst xmlns:a="http://schemas.openxmlformats.org/drawingml/2006/main">
               <a:ext uri="{FF2B5EF4-FFF2-40B4-BE49-F238E27FC236}">
-                <a16:creationId xmlns:a16="http://schemas.microsoft.com/office/drawing/2014/main" id="{1585FECA-2C46-4F67-8DBF-DA1ECBFD4B00}"/>
+                <a16:creationId xmlns:a16="http://schemas.microsoft.com/office/drawing/2014/main" id="{D1ED5363-B819-4020-A00E-CE4ACEF2BA62}"/>
               </a:ext>
             </a:extLst>
           </p:cNvPr>
@@ -6313,7 +6313,7 @@
     </p:spTree>
     <p:extLst>
       <p:ext uri="{BB962C8B-B14F-4D97-AF65-F5344CB8AC3E}">
-        <p14:creationId xmlns:p14="http://schemas.microsoft.com/office/powerpoint/2010/main" val="1642142862"/>
+        <p14:creationId xmlns:p14="http://schemas.microsoft.com/office/powerpoint/2010/main" val="1923945595"/>
       </p:ext>
     </p:extLst>
   </p:cSld>
@@ -6344,7 +6344,7 @@
           <p:cNvPr id="14" name="">
             <a:extLst xmlns:a="http://schemas.openxmlformats.org/drawingml/2006/main">
               <a:ext uri="{FF2B5EF4-FFF2-40B4-BE49-F238E27FC236}">
-                <a16:creationId xmlns:a16="http://schemas.microsoft.com/office/drawing/2014/main" id="{40F3228B-3FE8-4A9A-BA97-FC4224E3CE20}"/>
+                <a16:creationId xmlns:a16="http://schemas.microsoft.com/office/drawing/2014/main" id="{656C5E06-F99D-4AD1-ABA1-D69F03A8A9F9}"/>
               </a:ext>
             </a:extLst>
           </p:cNvPr>
@@ -6375,7 +6375,7 @@
           <p:cNvPr id="2" name="">
             <a:extLst xmlns:a="http://schemas.openxmlformats.org/drawingml/2006/main">
               <a:ext uri="{FF2B5EF4-FFF2-40B4-BE49-F238E27FC236}">
-                <a16:creationId xmlns:a16="http://schemas.microsoft.com/office/drawing/2014/main" id="{80BD4B6D-752A-4D03-92E8-A5F2E19F2A18}"/>
+                <a16:creationId xmlns:a16="http://schemas.microsoft.com/office/drawing/2014/main" id="{46860F3F-3784-4D64-B90E-F2425EF2BBA5}"/>
               </a:ext>
             </a:extLst>
           </p:cNvPr>
@@ -6444,7 +6444,7 @@
           <p:cNvPr id="3" name="">
             <a:extLst xmlns:a="http://schemas.openxmlformats.org/drawingml/2006/main">
               <a:ext uri="{FF2B5EF4-FFF2-40B4-BE49-F238E27FC236}">
-                <a16:creationId xmlns:a16="http://schemas.microsoft.com/office/drawing/2014/main" id="{6F9215B3-5EFA-4A5B-B0E1-BFE0415A952B}"/>
+                <a16:creationId xmlns:a16="http://schemas.microsoft.com/office/drawing/2014/main" id="{7D0CC876-0B95-4E80-ABD1-C1D0F3EFA357}"/>
               </a:ext>
             </a:extLst>
           </p:cNvPr>
@@ -6475,7 +6475,7 @@
           <p:cNvPr id="4" name="">
             <a:extLst xmlns:a="http://schemas.openxmlformats.org/drawingml/2006/main">
               <a:ext uri="{FF2B5EF4-FFF2-40B4-BE49-F238E27FC236}">
-                <a16:creationId xmlns:a16="http://schemas.microsoft.com/office/drawing/2014/main" id="{4FCCFD98-42B0-416E-9854-5DA128311C3C}"/>
+                <a16:creationId xmlns:a16="http://schemas.microsoft.com/office/drawing/2014/main" id="{6553041C-F3EB-425A-B7B3-32E80256FFAF}"/>
               </a:ext>
             </a:extLst>
           </p:cNvPr>
@@ -6544,7 +6544,7 @@
           <p:cNvPr id="5" name="">
             <a:extLst xmlns:a="http://schemas.openxmlformats.org/drawingml/2006/main">
               <a:ext uri="{FF2B5EF4-FFF2-40B4-BE49-F238E27FC236}">
-                <a16:creationId xmlns:a16="http://schemas.microsoft.com/office/drawing/2014/main" id="{E508894F-CEC5-4A08-8149-96F0F619FB36}"/>
+                <a16:creationId xmlns:a16="http://schemas.microsoft.com/office/drawing/2014/main" id="{702612E8-8487-497D-A816-75E6BA4B7224}"/>
               </a:ext>
             </a:extLst>
           </p:cNvPr>
@@ -6613,7 +6613,7 @@
           <p:cNvPr id="6" name="">
             <a:extLst xmlns:a="http://schemas.openxmlformats.org/drawingml/2006/main">
               <a:ext uri="{FF2B5EF4-FFF2-40B4-BE49-F238E27FC236}">
-                <a16:creationId xmlns:a16="http://schemas.microsoft.com/office/drawing/2014/main" id="{322FB58F-3901-4015-931B-7BA517662B2E}"/>
+                <a16:creationId xmlns:a16="http://schemas.microsoft.com/office/drawing/2014/main" id="{B9BDA9C1-58BA-4364-BC29-67AA59462190}"/>
               </a:ext>
             </a:extLst>
           </p:cNvPr>
@@ -6682,7 +6682,7 @@
           <p:cNvPr id="7" name="">
             <a:extLst xmlns:a="http://schemas.openxmlformats.org/drawingml/2006/main">
               <a:ext uri="{FF2B5EF4-FFF2-40B4-BE49-F238E27FC236}">
-                <a16:creationId xmlns:a16="http://schemas.microsoft.com/office/drawing/2014/main" id="{CE054127-6B1D-4F91-ADC8-03195ECD2B1C}"/>
+                <a16:creationId xmlns:a16="http://schemas.microsoft.com/office/drawing/2014/main" id="{657D08D4-0D65-4157-B562-96E020CD8E89}"/>
               </a:ext>
             </a:extLst>
           </p:cNvPr>
@@ -6774,7 +6774,7 @@
           <p:cNvPr id="8" name="">
             <a:extLst xmlns:a="http://schemas.openxmlformats.org/drawingml/2006/main">
               <a:ext uri="{FF2B5EF4-FFF2-40B4-BE49-F238E27FC236}">
-                <a16:creationId xmlns:a16="http://schemas.microsoft.com/office/drawing/2014/main" id="{65509F7D-A621-4552-A0EF-ABA988CC0081}"/>
+                <a16:creationId xmlns:a16="http://schemas.microsoft.com/office/drawing/2014/main" id="{F33CB7C0-E6E6-4D28-8527-08194DDDDF3A}"/>
               </a:ext>
             </a:extLst>
           </p:cNvPr>
@@ -6843,7 +6843,7 @@
           <p:cNvPr id="9" name="">
             <a:extLst xmlns:a="http://schemas.openxmlformats.org/drawingml/2006/main">
               <a:ext uri="{FF2B5EF4-FFF2-40B4-BE49-F238E27FC236}">
-                <a16:creationId xmlns:a16="http://schemas.microsoft.com/office/drawing/2014/main" id="{C36DC984-AD7B-4F7B-BEE8-6671BFE11ED4}"/>
+                <a16:creationId xmlns:a16="http://schemas.microsoft.com/office/drawing/2014/main" id="{AD00A1A7-A215-42F4-8C73-C3056587E076}"/>
               </a:ext>
             </a:extLst>
           </p:cNvPr>
@@ -6912,7 +6912,7 @@
           <p:cNvPr id="10" name="">
             <a:extLst xmlns:a="http://schemas.openxmlformats.org/drawingml/2006/main">
               <a:ext uri="{FF2B5EF4-FFF2-40B4-BE49-F238E27FC236}">
-                <a16:creationId xmlns:a16="http://schemas.microsoft.com/office/drawing/2014/main" id="{AAFA0474-9FA0-4C78-B0F4-C25B82521705}"/>
+                <a16:creationId xmlns:a16="http://schemas.microsoft.com/office/drawing/2014/main" id="{D37F8D92-FE24-4421-A55E-83DEBF33947F}"/>
               </a:ext>
             </a:extLst>
           </p:cNvPr>
@@ -6981,7 +6981,7 @@
           <p:cNvPr id="11" name="">
             <a:extLst xmlns:a="http://schemas.openxmlformats.org/drawingml/2006/main">
               <a:ext uri="{FF2B5EF4-FFF2-40B4-BE49-F238E27FC236}">
-                <a16:creationId xmlns:a16="http://schemas.microsoft.com/office/drawing/2014/main" id="{6B754017-D5F2-4882-BD0E-9DBE523894A2}"/>
+                <a16:creationId xmlns:a16="http://schemas.microsoft.com/office/drawing/2014/main" id="{FEC28458-9A4C-42CA-893C-EA91C09EE993}"/>
               </a:ext>
             </a:extLst>
           </p:cNvPr>
@@ -7012,7 +7012,7 @@
           <p:cNvPr id="12" name="">
             <a:extLst xmlns:a="http://schemas.openxmlformats.org/drawingml/2006/main">
               <a:ext uri="{FF2B5EF4-FFF2-40B4-BE49-F238E27FC236}">
-                <a16:creationId xmlns:a16="http://schemas.microsoft.com/office/drawing/2014/main" id="{05AA452E-1CC5-4904-A334-CCD675444B2B}"/>
+                <a16:creationId xmlns:a16="http://schemas.microsoft.com/office/drawing/2014/main" id="{2FE21496-6B29-4E4C-9A2E-AF94C924829C}"/>
               </a:ext>
             </a:extLst>
           </p:cNvPr>
@@ -7178,7 +7178,7 @@
           <p:cNvPr id="13" name="">
             <a:extLst xmlns:a="http://schemas.openxmlformats.org/drawingml/2006/main">
               <a:ext uri="{FF2B5EF4-FFF2-40B4-BE49-F238E27FC236}">
-                <a16:creationId xmlns:a16="http://schemas.microsoft.com/office/drawing/2014/main" id="{24AF52E6-3B4A-40FB-985B-CBD2603CFF87}"/>
+                <a16:creationId xmlns:a16="http://schemas.microsoft.com/office/drawing/2014/main" id="{EAA42FF8-C29F-4884-A6C3-11598999E759}"/>
               </a:ext>
             </a:extLst>
           </p:cNvPr>
@@ -7245,7 +7245,7 @@
     </p:spTree>
     <p:extLst>
       <p:ext uri="{BB962C8B-B14F-4D97-AF65-F5344CB8AC3E}">
-        <p14:creationId xmlns:p14="http://schemas.microsoft.com/office/powerpoint/2010/main" val="993719892"/>
+        <p14:creationId xmlns:p14="http://schemas.microsoft.com/office/powerpoint/2010/main" val="13527464"/>
       </p:ext>
     </p:extLst>
   </p:cSld>
@@ -7276,7 +7276,7 @@
           <p:cNvPr id="17" name="">
             <a:extLst xmlns:a="http://schemas.openxmlformats.org/drawingml/2006/main">
               <a:ext uri="{FF2B5EF4-FFF2-40B4-BE49-F238E27FC236}">
-                <a16:creationId xmlns:a16="http://schemas.microsoft.com/office/drawing/2014/main" id="{3F83666E-B44C-497F-BD78-183A1DEF39E6}"/>
+                <a16:creationId xmlns:a16="http://schemas.microsoft.com/office/drawing/2014/main" id="{C6CCCC1C-980C-4608-9001-909D55D9C737}"/>
               </a:ext>
             </a:extLst>
           </p:cNvPr>
@@ -7307,7 +7307,7 @@
           <p:cNvPr id="2" name="">
             <a:extLst xmlns:a="http://schemas.openxmlformats.org/drawingml/2006/main">
               <a:ext uri="{FF2B5EF4-FFF2-40B4-BE49-F238E27FC236}">
-                <a16:creationId xmlns:a16="http://schemas.microsoft.com/office/drawing/2014/main" id="{60ACAA69-CAD3-4308-963E-9AC8D0D2B7E4}"/>
+                <a16:creationId xmlns:a16="http://schemas.microsoft.com/office/drawing/2014/main" id="{32D0345E-754F-4104-8142-AAFA4D4C105B}"/>
               </a:ext>
             </a:extLst>
           </p:cNvPr>
@@ -7376,7 +7376,7 @@
           <p:cNvPr id="3" name="">
             <a:extLst xmlns:a="http://schemas.openxmlformats.org/drawingml/2006/main">
               <a:ext uri="{FF2B5EF4-FFF2-40B4-BE49-F238E27FC236}">
-                <a16:creationId xmlns:a16="http://schemas.microsoft.com/office/drawing/2014/main" id="{6DCEED1C-05CF-4139-9EE1-54B2A37AFADD}"/>
+                <a16:creationId xmlns:a16="http://schemas.microsoft.com/office/drawing/2014/main" id="{CAB7713E-B0B7-454B-93B0-FB1966AF289C}"/>
               </a:ext>
             </a:extLst>
           </p:cNvPr>
@@ -7407,7 +7407,7 @@
           <p:cNvPr id="4" name="">
             <a:extLst xmlns:a="http://schemas.openxmlformats.org/drawingml/2006/main">
               <a:ext uri="{FF2B5EF4-FFF2-40B4-BE49-F238E27FC236}">
-                <a16:creationId xmlns:a16="http://schemas.microsoft.com/office/drawing/2014/main" id="{B18A0BAF-8634-4835-ADED-F9C973146683}"/>
+                <a16:creationId xmlns:a16="http://schemas.microsoft.com/office/drawing/2014/main" id="{888B769B-F229-4CC6-84A2-3C1FA5624F66}"/>
               </a:ext>
             </a:extLst>
           </p:cNvPr>
@@ -7476,7 +7476,7 @@
           <p:cNvPr id="5" name="">
             <a:extLst xmlns:a="http://schemas.openxmlformats.org/drawingml/2006/main">
               <a:ext uri="{FF2B5EF4-FFF2-40B4-BE49-F238E27FC236}">
-                <a16:creationId xmlns:a16="http://schemas.microsoft.com/office/drawing/2014/main" id="{4D652657-51F2-4909-8192-B34F6F606FF9}"/>
+                <a16:creationId xmlns:a16="http://schemas.microsoft.com/office/drawing/2014/main" id="{EC40A9B2-D829-4D3B-9094-27EBB9F52531}"/>
               </a:ext>
             </a:extLst>
           </p:cNvPr>
@@ -7545,7 +7545,7 @@
           <p:cNvPr id="6" name="">
             <a:extLst xmlns:a="http://schemas.openxmlformats.org/drawingml/2006/main">
               <a:ext uri="{FF2B5EF4-FFF2-40B4-BE49-F238E27FC236}">
-                <a16:creationId xmlns:a16="http://schemas.microsoft.com/office/drawing/2014/main" id="{8ACBD1C4-8DDA-4755-AAD9-8156E14AAA94}"/>
+                <a16:creationId xmlns:a16="http://schemas.microsoft.com/office/drawing/2014/main" id="{A16D58F9-387C-40CA-9DC8-AB448EF1611D}"/>
               </a:ext>
             </a:extLst>
           </p:cNvPr>
@@ -7614,7 +7614,7 @@
           <p:cNvPr id="7" name="">
             <a:extLst xmlns:a="http://schemas.openxmlformats.org/drawingml/2006/main">
               <a:ext uri="{FF2B5EF4-FFF2-40B4-BE49-F238E27FC236}">
-                <a16:creationId xmlns:a16="http://schemas.microsoft.com/office/drawing/2014/main" id="{A6DB0708-1581-4E6A-9508-CB4A40EC8549}"/>
+                <a16:creationId xmlns:a16="http://schemas.microsoft.com/office/drawing/2014/main" id="{78E19F59-676E-4AE5-B33B-A6575C9965AA}"/>
               </a:ext>
             </a:extLst>
           </p:cNvPr>
@@ -7683,7 +7683,7 @@
           <p:cNvPr id="8" name="">
             <a:extLst xmlns:a="http://schemas.openxmlformats.org/drawingml/2006/main">
               <a:ext uri="{FF2B5EF4-FFF2-40B4-BE49-F238E27FC236}">
-                <a16:creationId xmlns:a16="http://schemas.microsoft.com/office/drawing/2014/main" id="{170972A8-EEE7-4440-AEA8-E0634739DD6F}"/>
+                <a16:creationId xmlns:a16="http://schemas.microsoft.com/office/drawing/2014/main" id="{A34D8E57-DA7A-45DC-BB91-57B56A1B6053}"/>
               </a:ext>
             </a:extLst>
           </p:cNvPr>
@@ -7714,7 +7714,7 @@
           <p:cNvPr id="9" name="">
             <a:extLst xmlns:a="http://schemas.openxmlformats.org/drawingml/2006/main">
               <a:ext uri="{FF2B5EF4-FFF2-40B4-BE49-F238E27FC236}">
-                <a16:creationId xmlns:a16="http://schemas.microsoft.com/office/drawing/2014/main" id="{D02517EB-475A-4418-ACF2-F754F915A3AC}"/>
+                <a16:creationId xmlns:a16="http://schemas.microsoft.com/office/drawing/2014/main" id="{BCF3A3C8-CAA0-4A7B-B057-BCFCE7D98835}"/>
               </a:ext>
             </a:extLst>
           </p:cNvPr>
@@ -7783,7 +7783,7 @@
           <p:cNvPr id="10" name="">
             <a:extLst xmlns:a="http://schemas.openxmlformats.org/drawingml/2006/main">
               <a:ext uri="{FF2B5EF4-FFF2-40B4-BE49-F238E27FC236}">
-                <a16:creationId xmlns:a16="http://schemas.microsoft.com/office/drawing/2014/main" id="{E51113A1-33E0-4FE2-A744-5D978E4E7096}"/>
+                <a16:creationId xmlns:a16="http://schemas.microsoft.com/office/drawing/2014/main" id="{ED406436-87AB-4FA4-B2A8-C932225652D2}"/>
               </a:ext>
             </a:extLst>
           </p:cNvPr>
@@ -7852,7 +7852,7 @@
           <p:cNvPr id="11" name="">
             <a:extLst xmlns:a="http://schemas.openxmlformats.org/drawingml/2006/main">
               <a:ext uri="{FF2B5EF4-FFF2-40B4-BE49-F238E27FC236}">
-                <a16:creationId xmlns:a16="http://schemas.microsoft.com/office/drawing/2014/main" id="{76DE293E-B288-4CD8-B501-33AFBBD44752}"/>
+                <a16:creationId xmlns:a16="http://schemas.microsoft.com/office/drawing/2014/main" id="{A094BE80-0376-4690-A574-D52231C6A811}"/>
               </a:ext>
             </a:extLst>
           </p:cNvPr>
@@ -7883,7 +7883,7 @@
           <p:cNvPr id="12" name="">
             <a:extLst xmlns:a="http://schemas.openxmlformats.org/drawingml/2006/main">
               <a:ext uri="{FF2B5EF4-FFF2-40B4-BE49-F238E27FC236}">
-                <a16:creationId xmlns:a16="http://schemas.microsoft.com/office/drawing/2014/main" id="{29BFC646-3433-44FE-83FC-3CBF9455970B}"/>
+                <a16:creationId xmlns:a16="http://schemas.microsoft.com/office/drawing/2014/main" id="{1648C1FF-9BBA-4A0C-BD37-CDFE71811C81}"/>
               </a:ext>
             </a:extLst>
           </p:cNvPr>
@@ -7952,7 +7952,7 @@
           <p:cNvPr id="13" name="">
             <a:extLst xmlns:a="http://schemas.openxmlformats.org/drawingml/2006/main">
               <a:ext uri="{FF2B5EF4-FFF2-40B4-BE49-F238E27FC236}">
-                <a16:creationId xmlns:a16="http://schemas.microsoft.com/office/drawing/2014/main" id="{953D8DD6-E011-4618-8B87-1E6B6F113F73}"/>
+                <a16:creationId xmlns:a16="http://schemas.microsoft.com/office/drawing/2014/main" id="{F814951C-8F11-4B9C-BD03-834B1FEAD086}"/>
               </a:ext>
             </a:extLst>
           </p:cNvPr>
@@ -8021,7 +8021,7 @@
           <p:cNvPr id="14" name="">
             <a:extLst xmlns:a="http://schemas.openxmlformats.org/drawingml/2006/main">
               <a:ext uri="{FF2B5EF4-FFF2-40B4-BE49-F238E27FC236}">
-                <a16:creationId xmlns:a16="http://schemas.microsoft.com/office/drawing/2014/main" id="{9123C351-08BD-4D3A-8520-473060E8B8CE}"/>
+                <a16:creationId xmlns:a16="http://schemas.microsoft.com/office/drawing/2014/main" id="{BC766056-DDC9-45CC-AD5F-D1F88E0BC133}"/>
               </a:ext>
             </a:extLst>
           </p:cNvPr>
@@ -8052,7 +8052,7 @@
           <p:cNvPr id="15" name="">
             <a:extLst xmlns:a="http://schemas.openxmlformats.org/drawingml/2006/main">
               <a:ext uri="{FF2B5EF4-FFF2-40B4-BE49-F238E27FC236}">
-                <a16:creationId xmlns:a16="http://schemas.microsoft.com/office/drawing/2014/main" id="{694540EB-27DF-4D45-974B-2E1BD84247A7}"/>
+                <a16:creationId xmlns:a16="http://schemas.microsoft.com/office/drawing/2014/main" id="{382D14D6-E3F3-4330-8F3C-84AF3BCBC0F6}"/>
               </a:ext>
             </a:extLst>
           </p:cNvPr>
@@ -8121,7 +8121,7 @@
           <p:cNvPr id="16" name="">
             <a:extLst xmlns:a="http://schemas.openxmlformats.org/drawingml/2006/main">
               <a:ext uri="{FF2B5EF4-FFF2-40B4-BE49-F238E27FC236}">
-                <a16:creationId xmlns:a16="http://schemas.microsoft.com/office/drawing/2014/main" id="{BBF768D0-CFBF-4CAE-ACB5-596AD9155CA1}"/>
+                <a16:creationId xmlns:a16="http://schemas.microsoft.com/office/drawing/2014/main" id="{E6E8BD3B-0C8D-4E7D-A3A3-8EC28734B14A}"/>
               </a:ext>
             </a:extLst>
           </p:cNvPr>
@@ -8188,7 +8188,7 @@
     </p:spTree>
     <p:extLst>
       <p:ext uri="{BB962C8B-B14F-4D97-AF65-F5344CB8AC3E}">
-        <p14:creationId xmlns:p14="http://schemas.microsoft.com/office/powerpoint/2010/main" val="1163864638"/>
+        <p14:creationId xmlns:p14="http://schemas.microsoft.com/office/powerpoint/2010/main" val="1231722613"/>
       </p:ext>
     </p:extLst>
   </p:cSld>
@@ -8219,7 +8219,7 @@
           <p:cNvPr id="17" name="">
             <a:extLst xmlns:a="http://schemas.openxmlformats.org/drawingml/2006/main">
               <a:ext uri="{FF2B5EF4-FFF2-40B4-BE49-F238E27FC236}">
-                <a16:creationId xmlns:a16="http://schemas.microsoft.com/office/drawing/2014/main" id="{23D87406-DD20-4929-936B-AB4879D00CC3}"/>
+                <a16:creationId xmlns:a16="http://schemas.microsoft.com/office/drawing/2014/main" id="{1A6E191D-73BD-4FB4-91B8-3B95DD366F1D}"/>
               </a:ext>
             </a:extLst>
           </p:cNvPr>
@@ -8250,7 +8250,7 @@
           <p:cNvPr id="2" name="">
             <a:extLst xmlns:a="http://schemas.openxmlformats.org/drawingml/2006/main">
               <a:ext uri="{FF2B5EF4-FFF2-40B4-BE49-F238E27FC236}">
-                <a16:creationId xmlns:a16="http://schemas.microsoft.com/office/drawing/2014/main" id="{AE63650F-9199-46A5-999B-FD3BC8335739}"/>
+                <a16:creationId xmlns:a16="http://schemas.microsoft.com/office/drawing/2014/main" id="{3B23F232-DC13-4C49-91CF-4BEFD7EEF721}"/>
               </a:ext>
             </a:extLst>
           </p:cNvPr>
@@ -8319,7 +8319,7 @@
           <p:cNvPr id="3" name="">
             <a:extLst xmlns:a="http://schemas.openxmlformats.org/drawingml/2006/main">
               <a:ext uri="{FF2B5EF4-FFF2-40B4-BE49-F238E27FC236}">
-                <a16:creationId xmlns:a16="http://schemas.microsoft.com/office/drawing/2014/main" id="{5C97C720-13D5-403A-980A-E4A7F830C3F8}"/>
+                <a16:creationId xmlns:a16="http://schemas.microsoft.com/office/drawing/2014/main" id="{7224035E-9575-4A9C-82F4-38BD9062E919}"/>
               </a:ext>
             </a:extLst>
           </p:cNvPr>
@@ -8350,7 +8350,7 @@
           <p:cNvPr id="4" name="">
             <a:extLst xmlns:a="http://schemas.openxmlformats.org/drawingml/2006/main">
               <a:ext uri="{FF2B5EF4-FFF2-40B4-BE49-F238E27FC236}">
-                <a16:creationId xmlns:a16="http://schemas.microsoft.com/office/drawing/2014/main" id="{0B53BE92-51D7-44A7-87C2-AAD8B1EC03DD}"/>
+                <a16:creationId xmlns:a16="http://schemas.microsoft.com/office/drawing/2014/main" id="{7627C775-C76F-42D1-922A-B630FFBC9C96}"/>
               </a:ext>
             </a:extLst>
           </p:cNvPr>
@@ -8419,7 +8419,7 @@
           <p:cNvPr id="5" name="">
             <a:extLst xmlns:a="http://schemas.openxmlformats.org/drawingml/2006/main">
               <a:ext uri="{FF2B5EF4-FFF2-40B4-BE49-F238E27FC236}">
-                <a16:creationId xmlns:a16="http://schemas.microsoft.com/office/drawing/2014/main" id="{1FD424B8-B867-4A12-9EAB-053AB623487E}"/>
+                <a16:creationId xmlns:a16="http://schemas.microsoft.com/office/drawing/2014/main" id="{BB099971-2282-417A-A4DC-783681BCB76F}"/>
               </a:ext>
             </a:extLst>
           </p:cNvPr>
@@ -8488,7 +8488,7 @@
           <p:cNvPr id="6" name="">
             <a:extLst xmlns:a="http://schemas.openxmlformats.org/drawingml/2006/main">
               <a:ext uri="{FF2B5EF4-FFF2-40B4-BE49-F238E27FC236}">
-                <a16:creationId xmlns:a16="http://schemas.microsoft.com/office/drawing/2014/main" id="{141C3F8D-144A-4217-BFD1-480B548FBAD1}"/>
+                <a16:creationId xmlns:a16="http://schemas.microsoft.com/office/drawing/2014/main" id="{D0EF2C46-9952-4EFE-9020-61DA92EACB70}"/>
               </a:ext>
             </a:extLst>
           </p:cNvPr>
@@ -8557,7 +8557,7 @@
           <p:cNvPr id="7" name="">
             <a:extLst xmlns:a="http://schemas.openxmlformats.org/drawingml/2006/main">
               <a:ext uri="{FF2B5EF4-FFF2-40B4-BE49-F238E27FC236}">
-                <a16:creationId xmlns:a16="http://schemas.microsoft.com/office/drawing/2014/main" id="{4AD003A6-CD67-445E-8508-B8A167FCAF6D}"/>
+                <a16:creationId xmlns:a16="http://schemas.microsoft.com/office/drawing/2014/main" id="{E6F7BF78-AFB7-4094-B3EB-DD3D5EA5958F}"/>
               </a:ext>
             </a:extLst>
           </p:cNvPr>
@@ -8626,7 +8626,7 @@
           <p:cNvPr id="8" name="">
             <a:extLst xmlns:a="http://schemas.openxmlformats.org/drawingml/2006/main">
               <a:ext uri="{FF2B5EF4-FFF2-40B4-BE49-F238E27FC236}">
-                <a16:creationId xmlns:a16="http://schemas.microsoft.com/office/drawing/2014/main" id="{E74449AA-C9AE-46BF-B81F-807525F7A63C}"/>
+                <a16:creationId xmlns:a16="http://schemas.microsoft.com/office/drawing/2014/main" id="{7B0A91A3-70E9-4AA4-9564-945BC97DB588}"/>
               </a:ext>
             </a:extLst>
           </p:cNvPr>
@@ -8657,7 +8657,7 @@
           <p:cNvPr id="9" name="">
             <a:extLst xmlns:a="http://schemas.openxmlformats.org/drawingml/2006/main">
               <a:ext uri="{FF2B5EF4-FFF2-40B4-BE49-F238E27FC236}">
-                <a16:creationId xmlns:a16="http://schemas.microsoft.com/office/drawing/2014/main" id="{421B73A5-CECA-46ED-9EF2-06EFE28A02DB}"/>
+                <a16:creationId xmlns:a16="http://schemas.microsoft.com/office/drawing/2014/main" id="{02B0054A-3CAF-482E-9312-7A72CEE4A106}"/>
               </a:ext>
             </a:extLst>
           </p:cNvPr>
@@ -8726,7 +8726,7 @@
           <p:cNvPr id="10" name="">
             <a:extLst xmlns:a="http://schemas.openxmlformats.org/drawingml/2006/main">
               <a:ext uri="{FF2B5EF4-FFF2-40B4-BE49-F238E27FC236}">
-                <a16:creationId xmlns:a16="http://schemas.microsoft.com/office/drawing/2014/main" id="{D3A9ED4A-CC17-4C3B-9AD2-CD078139D79F}"/>
+                <a16:creationId xmlns:a16="http://schemas.microsoft.com/office/drawing/2014/main" id="{370164D2-BEAB-491D-87A7-42B2D25BF692}"/>
               </a:ext>
             </a:extLst>
           </p:cNvPr>
@@ -8795,7 +8795,7 @@
           <p:cNvPr id="11" name="">
             <a:extLst xmlns:a="http://schemas.openxmlformats.org/drawingml/2006/main">
               <a:ext uri="{FF2B5EF4-FFF2-40B4-BE49-F238E27FC236}">
-                <a16:creationId xmlns:a16="http://schemas.microsoft.com/office/drawing/2014/main" id="{72776103-BCBD-42B5-BC0D-C7ABB1802B93}"/>
+                <a16:creationId xmlns:a16="http://schemas.microsoft.com/office/drawing/2014/main" id="{F2E9F5B9-5849-47CC-AC72-6186E9688B10}"/>
               </a:ext>
             </a:extLst>
           </p:cNvPr>
@@ -8826,7 +8826,7 @@
           <p:cNvPr id="12" name="">
             <a:extLst xmlns:a="http://schemas.openxmlformats.org/drawingml/2006/main">
               <a:ext uri="{FF2B5EF4-FFF2-40B4-BE49-F238E27FC236}">
-                <a16:creationId xmlns:a16="http://schemas.microsoft.com/office/drawing/2014/main" id="{FC257150-FBCA-4496-8395-B1F2679E67B5}"/>
+                <a16:creationId xmlns:a16="http://schemas.microsoft.com/office/drawing/2014/main" id="{8207F0C6-D104-4AFF-9FA2-048ADC351609}"/>
               </a:ext>
             </a:extLst>
           </p:cNvPr>
@@ -8895,7 +8895,7 @@
           <p:cNvPr id="13" name="">
             <a:extLst xmlns:a="http://schemas.openxmlformats.org/drawingml/2006/main">
               <a:ext uri="{FF2B5EF4-FFF2-40B4-BE49-F238E27FC236}">
-                <a16:creationId xmlns:a16="http://schemas.microsoft.com/office/drawing/2014/main" id="{FCFA053C-AA53-4684-ACF0-C22F4CFBBBE9}"/>
+                <a16:creationId xmlns:a16="http://schemas.microsoft.com/office/drawing/2014/main" id="{D933B322-A0A0-418E-9700-FEBE887837B8}"/>
               </a:ext>
             </a:extLst>
           </p:cNvPr>
@@ -8964,7 +8964,7 @@
           <p:cNvPr id="14" name="">
             <a:extLst xmlns:a="http://schemas.openxmlformats.org/drawingml/2006/main">
               <a:ext uri="{FF2B5EF4-FFF2-40B4-BE49-F238E27FC236}">
-                <a16:creationId xmlns:a16="http://schemas.microsoft.com/office/drawing/2014/main" id="{9E38F985-CA8A-4ECC-ABF9-D16370593D02}"/>
+                <a16:creationId xmlns:a16="http://schemas.microsoft.com/office/drawing/2014/main" id="{D8A428D0-E5EC-4E5A-9713-89AF2C4CBDEE}"/>
               </a:ext>
             </a:extLst>
           </p:cNvPr>
@@ -8995,7 +8995,7 @@
           <p:cNvPr id="15" name="">
             <a:extLst xmlns:a="http://schemas.openxmlformats.org/drawingml/2006/main">
               <a:ext uri="{FF2B5EF4-FFF2-40B4-BE49-F238E27FC236}">
-                <a16:creationId xmlns:a16="http://schemas.microsoft.com/office/drawing/2014/main" id="{D94BE578-4052-46FB-8AFD-2037CC3946F1}"/>
+                <a16:creationId xmlns:a16="http://schemas.microsoft.com/office/drawing/2014/main" id="{39FC9CE1-3260-4BCF-9F0F-857F5C80C4A4}"/>
               </a:ext>
             </a:extLst>
           </p:cNvPr>
@@ -9064,7 +9064,7 @@
           <p:cNvPr id="16" name="">
             <a:extLst xmlns:a="http://schemas.openxmlformats.org/drawingml/2006/main">
               <a:ext uri="{FF2B5EF4-FFF2-40B4-BE49-F238E27FC236}">
-                <a16:creationId xmlns:a16="http://schemas.microsoft.com/office/drawing/2014/main" id="{6A873CEA-36C5-4996-8E8A-FCC54F79AD9A}"/>
+                <a16:creationId xmlns:a16="http://schemas.microsoft.com/office/drawing/2014/main" id="{C77C84E9-A95C-4FDA-AB24-EF2BD79A5A9B}"/>
               </a:ext>
             </a:extLst>
           </p:cNvPr>
@@ -9131,7 +9131,7 @@
     </p:spTree>
     <p:extLst>
       <p:ext uri="{BB962C8B-B14F-4D97-AF65-F5344CB8AC3E}">
-        <p14:creationId xmlns:p14="http://schemas.microsoft.com/office/powerpoint/2010/main" val="705000104"/>
+        <p14:creationId xmlns:p14="http://schemas.microsoft.com/office/powerpoint/2010/main" val="1706187095"/>
       </p:ext>
     </p:extLst>
   </p:cSld>
@@ -9162,7 +9162,7 @@
           <p:cNvPr id="11" name="">
             <a:extLst xmlns:a="http://schemas.openxmlformats.org/drawingml/2006/main">
               <a:ext uri="{FF2B5EF4-FFF2-40B4-BE49-F238E27FC236}">
-                <a16:creationId xmlns:a16="http://schemas.microsoft.com/office/drawing/2014/main" id="{3AF5BA65-BB71-4B24-BE0A-142315383A12}"/>
+                <a16:creationId xmlns:a16="http://schemas.microsoft.com/office/drawing/2014/main" id="{389E171C-5430-4B52-A6E8-65116D7D31B0}"/>
               </a:ext>
             </a:extLst>
           </p:cNvPr>
@@ -9193,7 +9193,7 @@
           <p:cNvPr id="2" name="">
             <a:extLst xmlns:a="http://schemas.openxmlformats.org/drawingml/2006/main">
               <a:ext uri="{FF2B5EF4-FFF2-40B4-BE49-F238E27FC236}">
-                <a16:creationId xmlns:a16="http://schemas.microsoft.com/office/drawing/2014/main" id="{3B193481-258C-4780-80C8-90AFF95894D2}"/>
+                <a16:creationId xmlns:a16="http://schemas.microsoft.com/office/drawing/2014/main" id="{9D3E03F7-5ABF-4B62-8B50-8904BD07E6F6}"/>
               </a:ext>
             </a:extLst>
           </p:cNvPr>
@@ -9262,7 +9262,7 @@
           <p:cNvPr id="3" name="">
             <a:extLst xmlns:a="http://schemas.openxmlformats.org/drawingml/2006/main">
               <a:ext uri="{FF2B5EF4-FFF2-40B4-BE49-F238E27FC236}">
-                <a16:creationId xmlns:a16="http://schemas.microsoft.com/office/drawing/2014/main" id="{0E3E191D-97FA-4B10-A38A-B1DD348442F0}"/>
+                <a16:creationId xmlns:a16="http://schemas.microsoft.com/office/drawing/2014/main" id="{87FF9C88-065A-4C08-9F8C-C9AC29B2BBC5}"/>
               </a:ext>
             </a:extLst>
           </p:cNvPr>
@@ -9293,7 +9293,7 @@
           <p:cNvPr id="4" name="">
             <a:extLst xmlns:a="http://schemas.openxmlformats.org/drawingml/2006/main">
               <a:ext uri="{FF2B5EF4-FFF2-40B4-BE49-F238E27FC236}">
-                <a16:creationId xmlns:a16="http://schemas.microsoft.com/office/drawing/2014/main" id="{9B1BA87E-4182-4CCD-902F-AB2EB95DF49F}"/>
+                <a16:creationId xmlns:a16="http://schemas.microsoft.com/office/drawing/2014/main" id="{7ECEAE61-3144-4C61-9F8E-E3AC7907342A}"/>
               </a:ext>
             </a:extLst>
           </p:cNvPr>
@@ -9362,7 +9362,7 @@
           <p:cNvPr id="5" name="">
             <a:extLst xmlns:a="http://schemas.openxmlformats.org/drawingml/2006/main">
               <a:ext uri="{FF2B5EF4-FFF2-40B4-BE49-F238E27FC236}">
-                <a16:creationId xmlns:a16="http://schemas.microsoft.com/office/drawing/2014/main" id="{403CB44E-D75F-4FBB-9D70-33FF08AC5BDB}"/>
+                <a16:creationId xmlns:a16="http://schemas.microsoft.com/office/drawing/2014/main" id="{CA81ED91-839C-4EF3-862D-D3715F4480DB}"/>
               </a:ext>
             </a:extLst>
           </p:cNvPr>
@@ -9431,7 +9431,7 @@
           <p:cNvPr id="6" name="">
             <a:extLst xmlns:a="http://schemas.openxmlformats.org/drawingml/2006/main">
               <a:ext uri="{FF2B5EF4-FFF2-40B4-BE49-F238E27FC236}">
-                <a16:creationId xmlns:a16="http://schemas.microsoft.com/office/drawing/2014/main" id="{58D8748C-8A9E-405B-9ECB-BA5288E4DD9E}"/>
+                <a16:creationId xmlns:a16="http://schemas.microsoft.com/office/drawing/2014/main" id="{E1956673-7AA6-438D-A3E8-5C16BF3AF346}"/>
               </a:ext>
             </a:extLst>
           </p:cNvPr>
@@ -9523,7 +9523,7 @@
           <p:cNvPr id="7" name="">
             <a:extLst xmlns:a="http://schemas.openxmlformats.org/drawingml/2006/main">
               <a:ext uri="{FF2B5EF4-FFF2-40B4-BE49-F238E27FC236}">
-                <a16:creationId xmlns:a16="http://schemas.microsoft.com/office/drawing/2014/main" id="{0FA2256A-2E7E-4418-BDA5-69CA855EE1E1}"/>
+                <a16:creationId xmlns:a16="http://schemas.microsoft.com/office/drawing/2014/main" id="{45339416-4044-477B-9B0C-0B8E0B58DB38}"/>
               </a:ext>
             </a:extLst>
           </p:cNvPr>
@@ -9592,7 +9592,7 @@
           <p:cNvPr id="8" name="">
             <a:extLst xmlns:a="http://schemas.openxmlformats.org/drawingml/2006/main">
               <a:ext uri="{FF2B5EF4-FFF2-40B4-BE49-F238E27FC236}">
-                <a16:creationId xmlns:a16="http://schemas.microsoft.com/office/drawing/2014/main" id="{71851830-C3B7-4434-9ACE-2E82E1A3F85A}"/>
+                <a16:creationId xmlns:a16="http://schemas.microsoft.com/office/drawing/2014/main" id="{E7307F82-D358-4555-816E-33ACEB6A7DDC}"/>
               </a:ext>
             </a:extLst>
           </p:cNvPr>
@@ -9684,7 +9684,7 @@
           <p:cNvPr id="9" name="">
             <a:extLst xmlns:a="http://schemas.openxmlformats.org/drawingml/2006/main">
               <a:ext uri="{FF2B5EF4-FFF2-40B4-BE49-F238E27FC236}">
-                <a16:creationId xmlns:a16="http://schemas.microsoft.com/office/drawing/2014/main" id="{14ED7D1D-6C33-4529-941F-53DC82092544}"/>
+                <a16:creationId xmlns:a16="http://schemas.microsoft.com/office/drawing/2014/main" id="{7CC1F405-F5E6-4466-8C56-8A845B467A49}"/>
               </a:ext>
             </a:extLst>
           </p:cNvPr>
@@ -9753,7 +9753,7 @@
           <p:cNvPr id="10" name="">
             <a:extLst xmlns:a="http://schemas.openxmlformats.org/drawingml/2006/main">
               <a:ext uri="{FF2B5EF4-FFF2-40B4-BE49-F238E27FC236}">
-                <a16:creationId xmlns:a16="http://schemas.microsoft.com/office/drawing/2014/main" id="{E5D88DCD-B2D4-4674-A5A8-C92618E30BE0}"/>
+                <a16:creationId xmlns:a16="http://schemas.microsoft.com/office/drawing/2014/main" id="{CAA2D027-28CF-42B5-8125-55E722863747}"/>
               </a:ext>
             </a:extLst>
           </p:cNvPr>
@@ -9843,7 +9843,7 @@
     </p:spTree>
     <p:extLst>
       <p:ext uri="{BB962C8B-B14F-4D97-AF65-F5344CB8AC3E}">
-        <p14:creationId xmlns:p14="http://schemas.microsoft.com/office/powerpoint/2010/main" val="1641648412"/>
+        <p14:creationId xmlns:p14="http://schemas.microsoft.com/office/powerpoint/2010/main" val="426007147"/>
       </p:ext>
     </p:extLst>
   </p:cSld>
@@ -9874,7 +9874,7 @@
           <p:cNvPr id="15" name="">
             <a:extLst xmlns:a="http://schemas.openxmlformats.org/drawingml/2006/main">
               <a:ext uri="{FF2B5EF4-FFF2-40B4-BE49-F238E27FC236}">
-                <a16:creationId xmlns:a16="http://schemas.microsoft.com/office/drawing/2014/main" id="{7B05180E-ADD4-4E57-B713-B2CE6D9BE535}"/>
+                <a16:creationId xmlns:a16="http://schemas.microsoft.com/office/drawing/2014/main" id="{C6A758D4-8A39-4172-A444-98FC1B2A22F9}"/>
               </a:ext>
             </a:extLst>
           </p:cNvPr>
@@ -9905,7 +9905,7 @@
           <p:cNvPr id="2" name="">
             <a:extLst xmlns:a="http://schemas.openxmlformats.org/drawingml/2006/main">
               <a:ext uri="{FF2B5EF4-FFF2-40B4-BE49-F238E27FC236}">
-                <a16:creationId xmlns:a16="http://schemas.microsoft.com/office/drawing/2014/main" id="{65ECF7E5-CB21-4839-85E1-562119AD8DDE}"/>
+                <a16:creationId xmlns:a16="http://schemas.microsoft.com/office/drawing/2014/main" id="{CF2A37B7-DFBE-48EC-823B-D5C200386DA3}"/>
               </a:ext>
             </a:extLst>
           </p:cNvPr>
@@ -9974,7 +9974,7 @@
           <p:cNvPr id="3" name="">
             <a:extLst xmlns:a="http://schemas.openxmlformats.org/drawingml/2006/main">
               <a:ext uri="{FF2B5EF4-FFF2-40B4-BE49-F238E27FC236}">
-                <a16:creationId xmlns:a16="http://schemas.microsoft.com/office/drawing/2014/main" id="{316F46A9-2754-416D-A2C5-F0AFCC440362}"/>
+                <a16:creationId xmlns:a16="http://schemas.microsoft.com/office/drawing/2014/main" id="{87E132DE-BDE4-46DF-A2D5-B5113BB06D62}"/>
               </a:ext>
             </a:extLst>
           </p:cNvPr>
@@ -10005,7 +10005,7 @@
           <p:cNvPr id="4" name="">
             <a:extLst xmlns:a="http://schemas.openxmlformats.org/drawingml/2006/main">
               <a:ext uri="{FF2B5EF4-FFF2-40B4-BE49-F238E27FC236}">
-                <a16:creationId xmlns:a16="http://schemas.microsoft.com/office/drawing/2014/main" id="{0CEA8933-1AD1-48AE-A59A-B08956317D73}"/>
+                <a16:creationId xmlns:a16="http://schemas.microsoft.com/office/drawing/2014/main" id="{627C0A1B-4982-4CAA-8589-61B4F5F441C4}"/>
               </a:ext>
             </a:extLst>
           </p:cNvPr>
@@ -10074,7 +10074,7 @@
           <p:cNvPr id="5" name="">
             <a:extLst xmlns:a="http://schemas.openxmlformats.org/drawingml/2006/main">
               <a:ext uri="{FF2B5EF4-FFF2-40B4-BE49-F238E27FC236}">
-                <a16:creationId xmlns:a16="http://schemas.microsoft.com/office/drawing/2014/main" id="{54C94517-65B5-45A1-9201-7B3A69EFF67C}"/>
+                <a16:creationId xmlns:a16="http://schemas.microsoft.com/office/drawing/2014/main" id="{0936434F-A1A1-4AF6-912F-B8F212D193A7}"/>
               </a:ext>
             </a:extLst>
           </p:cNvPr>
@@ -10143,7 +10143,7 @@
           <p:cNvPr id="6" name="">
             <a:extLst xmlns:a="http://schemas.openxmlformats.org/drawingml/2006/main">
               <a:ext uri="{FF2B5EF4-FFF2-40B4-BE49-F238E27FC236}">
-                <a16:creationId xmlns:a16="http://schemas.microsoft.com/office/drawing/2014/main" id="{B0C76869-64D5-43C8-A527-61E417077986}"/>
+                <a16:creationId xmlns:a16="http://schemas.microsoft.com/office/drawing/2014/main" id="{E046D98B-9388-45AA-A3CC-A609E7F4EF19}"/>
               </a:ext>
             </a:extLst>
           </p:cNvPr>
@@ -10235,7 +10235,7 @@
           <p:cNvPr id="7" name="">
             <a:extLst xmlns:a="http://schemas.openxmlformats.org/drawingml/2006/main">
               <a:ext uri="{FF2B5EF4-FFF2-40B4-BE49-F238E27FC236}">
-                <a16:creationId xmlns:a16="http://schemas.microsoft.com/office/drawing/2014/main" id="{999537DC-2EB9-4332-953E-B04BD4791031}"/>
+                <a16:creationId xmlns:a16="http://schemas.microsoft.com/office/drawing/2014/main" id="{4DF680B5-4FC5-4C34-A94F-03AAE056B01D}"/>
               </a:ext>
             </a:extLst>
           </p:cNvPr>
@@ -10304,7 +10304,7 @@
           <p:cNvPr id="8" name="">
             <a:extLst xmlns:a="http://schemas.openxmlformats.org/drawingml/2006/main">
               <a:ext uri="{FF2B5EF4-FFF2-40B4-BE49-F238E27FC236}">
-                <a16:creationId xmlns:a16="http://schemas.microsoft.com/office/drawing/2014/main" id="{D812CD93-7F7B-4A5B-8030-76E1FEC2B1E8}"/>
+                <a16:creationId xmlns:a16="http://schemas.microsoft.com/office/drawing/2014/main" id="{269155E1-D92A-454C-8B04-DD991944C43B}"/>
               </a:ext>
             </a:extLst>
           </p:cNvPr>
@@ -10373,7 +10373,7 @@
           <p:cNvPr id="9" name="">
             <a:extLst xmlns:a="http://schemas.openxmlformats.org/drawingml/2006/main">
               <a:ext uri="{FF2B5EF4-FFF2-40B4-BE49-F238E27FC236}">
-                <a16:creationId xmlns:a16="http://schemas.microsoft.com/office/drawing/2014/main" id="{72650E27-9D8B-4BE7-B306-A76C9F115CFE}"/>
+                <a16:creationId xmlns:a16="http://schemas.microsoft.com/office/drawing/2014/main" id="{EC9285CB-1EED-4D69-AA19-41877F624404}"/>
               </a:ext>
             </a:extLst>
           </p:cNvPr>
@@ -10404,7 +10404,7 @@
           <p:cNvPr id="10" name="">
             <a:extLst xmlns:a="http://schemas.openxmlformats.org/drawingml/2006/main">
               <a:ext uri="{FF2B5EF4-FFF2-40B4-BE49-F238E27FC236}">
-                <a16:creationId xmlns:a16="http://schemas.microsoft.com/office/drawing/2014/main" id="{F692BEC7-BA64-41E9-8CF1-AD5BB5CB31FB}"/>
+                <a16:creationId xmlns:a16="http://schemas.microsoft.com/office/drawing/2014/main" id="{6039029A-B07C-45C7-9FDF-CBA387BC2AB1}"/>
               </a:ext>
             </a:extLst>
           </p:cNvPr>
@@ -10473,7 +10473,7 @@
           <p:cNvPr id="11" name="">
             <a:extLst xmlns:a="http://schemas.openxmlformats.org/drawingml/2006/main">
               <a:ext uri="{FF2B5EF4-FFF2-40B4-BE49-F238E27FC236}">
-                <a16:creationId xmlns:a16="http://schemas.microsoft.com/office/drawing/2014/main" id="{81FFF2AD-C1FC-48E2-9C99-6BA8D28F82FB}"/>
+                <a16:creationId xmlns:a16="http://schemas.microsoft.com/office/drawing/2014/main" id="{1BB70F97-3FF0-4EDA-B5DB-B6D2B29BE1F5}"/>
               </a:ext>
             </a:extLst>
           </p:cNvPr>
@@ -10542,7 +10542,7 @@
           <p:cNvPr id="12" name="">
             <a:extLst xmlns:a="http://schemas.openxmlformats.org/drawingml/2006/main">
               <a:ext uri="{FF2B5EF4-FFF2-40B4-BE49-F238E27FC236}">
-                <a16:creationId xmlns:a16="http://schemas.microsoft.com/office/drawing/2014/main" id="{5AD62C49-2098-46E2-AA45-AB192C4B909D}"/>
+                <a16:creationId xmlns:a16="http://schemas.microsoft.com/office/drawing/2014/main" id="{8494551B-C055-42BE-9349-702066E83456}"/>
               </a:ext>
             </a:extLst>
           </p:cNvPr>
@@ -10573,7 +10573,7 @@
           <p:cNvPr id="13" name="">
             <a:extLst xmlns:a="http://schemas.openxmlformats.org/drawingml/2006/main">
               <a:ext uri="{FF2B5EF4-FFF2-40B4-BE49-F238E27FC236}">
-                <a16:creationId xmlns:a16="http://schemas.microsoft.com/office/drawing/2014/main" id="{050B1709-E779-44A1-8440-350A57C1DB62}"/>
+                <a16:creationId xmlns:a16="http://schemas.microsoft.com/office/drawing/2014/main" id="{E2D8D5DC-72BD-4F1E-9FC9-F7648B331178}"/>
               </a:ext>
             </a:extLst>
           </p:cNvPr>
@@ -10642,7 +10642,7 @@
           <p:cNvPr id="14" name="">
             <a:extLst xmlns:a="http://schemas.openxmlformats.org/drawingml/2006/main">
               <a:ext uri="{FF2B5EF4-FFF2-40B4-BE49-F238E27FC236}">
-                <a16:creationId xmlns:a16="http://schemas.microsoft.com/office/drawing/2014/main" id="{6ECE70E3-488F-4539-90DC-537A7D0DD820}"/>
+                <a16:creationId xmlns:a16="http://schemas.microsoft.com/office/drawing/2014/main" id="{81E55627-F99B-4F08-98BD-EC79C33A8527}"/>
               </a:ext>
             </a:extLst>
           </p:cNvPr>
@@ -10709,7 +10709,7 @@
     </p:spTree>
     <p:extLst>
       <p:ext uri="{BB962C8B-B14F-4D97-AF65-F5344CB8AC3E}">
-        <p14:creationId xmlns:p14="http://schemas.microsoft.com/office/powerpoint/2010/main" val="75098269"/>
+        <p14:creationId xmlns:p14="http://schemas.microsoft.com/office/powerpoint/2010/main" val="1479648745"/>
       </p:ext>
     </p:extLst>
   </p:cSld>
@@ -10740,7 +10740,7 @@
           <p:cNvPr id="7" name="">
             <a:extLst xmlns:a="http://schemas.openxmlformats.org/drawingml/2006/main">
               <a:ext uri="{FF2B5EF4-FFF2-40B4-BE49-F238E27FC236}">
-                <a16:creationId xmlns:a16="http://schemas.microsoft.com/office/drawing/2014/main" id="{5113123A-8B03-4477-A4F7-51ED06652DBB}"/>
+                <a16:creationId xmlns:a16="http://schemas.microsoft.com/office/drawing/2014/main" id="{FED4E54F-2928-4B11-BAA5-D87BFC5707F7}"/>
               </a:ext>
             </a:extLst>
           </p:cNvPr>
@@ -10771,7 +10771,7 @@
           <p:cNvPr id="2" name="">
             <a:extLst xmlns:a="http://schemas.openxmlformats.org/drawingml/2006/main">
               <a:ext uri="{FF2B5EF4-FFF2-40B4-BE49-F238E27FC236}">
-                <a16:creationId xmlns:a16="http://schemas.microsoft.com/office/drawing/2014/main" id="{0D279AB3-7542-4034-9C2F-938A5763C884}"/>
+                <a16:creationId xmlns:a16="http://schemas.microsoft.com/office/drawing/2014/main" id="{2194E4E7-A4DF-434D-84CB-B68E69340AC2}"/>
               </a:ext>
             </a:extLst>
           </p:cNvPr>
@@ -10840,7 +10840,7 @@
           <p:cNvPr id="3" name="">
             <a:extLst xmlns:a="http://schemas.openxmlformats.org/drawingml/2006/main">
               <a:ext uri="{FF2B5EF4-FFF2-40B4-BE49-F238E27FC236}">
-                <a16:creationId xmlns:a16="http://schemas.microsoft.com/office/drawing/2014/main" id="{19967B55-03FE-46B6-90F2-32A42A9B592C}"/>
+                <a16:creationId xmlns:a16="http://schemas.microsoft.com/office/drawing/2014/main" id="{5AFDCBF2-2673-4820-A5D7-89D87DC89B8C}"/>
               </a:ext>
             </a:extLst>
           </p:cNvPr>
@@ -10871,7 +10871,7 @@
           <p:cNvPr id="4" name="">
             <a:extLst xmlns:a="http://schemas.openxmlformats.org/drawingml/2006/main">
               <a:ext uri="{FF2B5EF4-FFF2-40B4-BE49-F238E27FC236}">
-                <a16:creationId xmlns:a16="http://schemas.microsoft.com/office/drawing/2014/main" id="{12B93D22-CE3B-456F-A6B8-B129E78B9105}"/>
+                <a16:creationId xmlns:a16="http://schemas.microsoft.com/office/drawing/2014/main" id="{A616C247-AF83-4827-901F-7B0F2475A11B}"/>
               </a:ext>
             </a:extLst>
           </p:cNvPr>
@@ -10940,7 +10940,7 @@
           <p:cNvPr id="5" name="">
             <a:extLst xmlns:a="http://schemas.openxmlformats.org/drawingml/2006/main">
               <a:ext uri="{FF2B5EF4-FFF2-40B4-BE49-F238E27FC236}">
-                <a16:creationId xmlns:a16="http://schemas.microsoft.com/office/drawing/2014/main" id="{10290290-7AF3-481B-ACAE-2410B2D594FB}"/>
+                <a16:creationId xmlns:a16="http://schemas.microsoft.com/office/drawing/2014/main" id="{8CAA1D1F-813C-4DEE-ADF8-247F89A2274D}"/>
               </a:ext>
             </a:extLst>
           </p:cNvPr>
@@ -11009,7 +11009,7 @@
           <p:cNvPr id="6" name="">
             <a:extLst xmlns:a="http://schemas.openxmlformats.org/drawingml/2006/main">
               <a:ext uri="{FF2B5EF4-FFF2-40B4-BE49-F238E27FC236}">
-                <a16:creationId xmlns:a16="http://schemas.microsoft.com/office/drawing/2014/main" id="{70AB6C15-2D28-4560-AF22-51B3DE20938D}"/>
+                <a16:creationId xmlns:a16="http://schemas.microsoft.com/office/drawing/2014/main" id="{0575F50C-29B5-4827-921D-CE84E398200C}"/>
               </a:ext>
             </a:extLst>
           </p:cNvPr>
@@ -11518,7 +11518,7 @@
     </p:spTree>
     <p:extLst>
       <p:ext uri="{BB962C8B-B14F-4D97-AF65-F5344CB8AC3E}">
-        <p14:creationId xmlns:p14="http://schemas.microsoft.com/office/powerpoint/2010/main" val="1004191133"/>
+        <p14:creationId xmlns:p14="http://schemas.microsoft.com/office/powerpoint/2010/main" val="1512133538"/>
       </p:ext>
     </p:extLst>
   </p:cSld>
@@ -11549,7 +11549,7 @@
           <p:cNvPr id="7" name="">
             <a:extLst xmlns:a="http://schemas.openxmlformats.org/drawingml/2006/main">
               <a:ext uri="{FF2B5EF4-FFF2-40B4-BE49-F238E27FC236}">
-                <a16:creationId xmlns:a16="http://schemas.microsoft.com/office/drawing/2014/main" id="{83CAFAB6-6B1D-4761-8E01-A4C2A30C0BFE}"/>
+                <a16:creationId xmlns:a16="http://schemas.microsoft.com/office/drawing/2014/main" id="{28C143DE-53E9-48CA-9924-7C890F85618C}"/>
               </a:ext>
             </a:extLst>
           </p:cNvPr>
@@ -11580,7 +11580,7 @@
           <p:cNvPr id="2" name="">
             <a:extLst xmlns:a="http://schemas.openxmlformats.org/drawingml/2006/main">
               <a:ext uri="{FF2B5EF4-FFF2-40B4-BE49-F238E27FC236}">
-                <a16:creationId xmlns:a16="http://schemas.microsoft.com/office/drawing/2014/main" id="{9689E2E9-CFA2-4227-99B9-2D9C5EEAD447}"/>
+                <a16:creationId xmlns:a16="http://schemas.microsoft.com/office/drawing/2014/main" id="{DC7F3431-7CAB-48BD-9DD2-528495B908F8}"/>
               </a:ext>
             </a:extLst>
           </p:cNvPr>
@@ -11649,7 +11649,7 @@
           <p:cNvPr id="3" name="">
             <a:extLst xmlns:a="http://schemas.openxmlformats.org/drawingml/2006/main">
               <a:ext uri="{FF2B5EF4-FFF2-40B4-BE49-F238E27FC236}">
-                <a16:creationId xmlns:a16="http://schemas.microsoft.com/office/drawing/2014/main" id="{CC132A69-6CA9-4D32-A406-6F2C72178C7B}"/>
+                <a16:creationId xmlns:a16="http://schemas.microsoft.com/office/drawing/2014/main" id="{A1B016EA-F793-40B2-8405-E6413205534C}"/>
               </a:ext>
             </a:extLst>
           </p:cNvPr>
@@ -11680,7 +11680,7 @@
           <p:cNvPr id="4" name="">
             <a:extLst xmlns:a="http://schemas.openxmlformats.org/drawingml/2006/main">
               <a:ext uri="{FF2B5EF4-FFF2-40B4-BE49-F238E27FC236}">
-                <a16:creationId xmlns:a16="http://schemas.microsoft.com/office/drawing/2014/main" id="{583D18E2-1F7F-4C47-BA0C-118169D259DB}"/>
+                <a16:creationId xmlns:a16="http://schemas.microsoft.com/office/drawing/2014/main" id="{78FD4696-2450-4F66-8FC5-BC176CC02B5C}"/>
               </a:ext>
             </a:extLst>
           </p:cNvPr>
@@ -11749,7 +11749,7 @@
           <p:cNvPr id="5" name="">
             <a:extLst xmlns:a="http://schemas.openxmlformats.org/drawingml/2006/main">
               <a:ext uri="{FF2B5EF4-FFF2-40B4-BE49-F238E27FC236}">
-                <a16:creationId xmlns:a16="http://schemas.microsoft.com/office/drawing/2014/main" id="{6578E606-A142-41D5-BA41-5E3FE1B20302}"/>
+                <a16:creationId xmlns:a16="http://schemas.microsoft.com/office/drawing/2014/main" id="{EBE8AD95-0D27-460B-A3EC-7CB4068F8427}"/>
               </a:ext>
             </a:extLst>
           </p:cNvPr>
@@ -11818,7 +11818,7 @@
           <p:cNvPr id="6" name="">
             <a:extLst xmlns:a="http://schemas.openxmlformats.org/drawingml/2006/main">
               <a:ext uri="{FF2B5EF4-FFF2-40B4-BE49-F238E27FC236}">
-                <a16:creationId xmlns:a16="http://schemas.microsoft.com/office/drawing/2014/main" id="{03F22FF6-C05C-47ED-9F55-F3BFCFB62BEB}"/>
+                <a16:creationId xmlns:a16="http://schemas.microsoft.com/office/drawing/2014/main" id="{CDA6499D-082C-440F-B9A6-558FDCA0B0A8}"/>
               </a:ext>
             </a:extLst>
           </p:cNvPr>
@@ -12443,7 +12443,7 @@
     </p:spTree>
     <p:extLst>
       <p:ext uri="{BB962C8B-B14F-4D97-AF65-F5344CB8AC3E}">
-        <p14:creationId xmlns:p14="http://schemas.microsoft.com/office/powerpoint/2010/main" val="1569192899"/>
+        <p14:creationId xmlns:p14="http://schemas.microsoft.com/office/powerpoint/2010/main" val="489743678"/>
       </p:ext>
     </p:extLst>
   </p:cSld>
@@ -12474,7 +12474,7 @@
           <p:cNvPr id="7" name="">
             <a:extLst xmlns:a="http://schemas.openxmlformats.org/drawingml/2006/main">
               <a:ext uri="{FF2B5EF4-FFF2-40B4-BE49-F238E27FC236}">
-                <a16:creationId xmlns:a16="http://schemas.microsoft.com/office/drawing/2014/main" id="{6BB3386E-F78F-4A81-BE20-0E5794AD464E}"/>
+                <a16:creationId xmlns:a16="http://schemas.microsoft.com/office/drawing/2014/main" id="{7E97E0A2-1EC7-45C1-8962-BFBF5E203FB8}"/>
               </a:ext>
             </a:extLst>
           </p:cNvPr>
@@ -12505,7 +12505,7 @@
           <p:cNvPr id="2" name="">
             <a:extLst xmlns:a="http://schemas.openxmlformats.org/drawingml/2006/main">
               <a:ext uri="{FF2B5EF4-FFF2-40B4-BE49-F238E27FC236}">
-                <a16:creationId xmlns:a16="http://schemas.microsoft.com/office/drawing/2014/main" id="{651C8C4B-87DA-4D7D-914D-EF2F53A83CAD}"/>
+                <a16:creationId xmlns:a16="http://schemas.microsoft.com/office/drawing/2014/main" id="{61F914E2-AA32-4D6A-A5C5-39B3A24E8A74}"/>
               </a:ext>
             </a:extLst>
           </p:cNvPr>
@@ -12574,7 +12574,7 @@
           <p:cNvPr id="3" name="">
             <a:extLst xmlns:a="http://schemas.openxmlformats.org/drawingml/2006/main">
               <a:ext uri="{FF2B5EF4-FFF2-40B4-BE49-F238E27FC236}">
-                <a16:creationId xmlns:a16="http://schemas.microsoft.com/office/drawing/2014/main" id="{B11A7808-0CB3-4558-9DBB-F876B680AA5E}"/>
+                <a16:creationId xmlns:a16="http://schemas.microsoft.com/office/drawing/2014/main" id="{2F1E6073-F4C4-4F4A-8AFF-3227259D155A}"/>
               </a:ext>
             </a:extLst>
           </p:cNvPr>
@@ -12605,7 +12605,7 @@
           <p:cNvPr id="4" name="">
             <a:extLst xmlns:a="http://schemas.openxmlformats.org/drawingml/2006/main">
               <a:ext uri="{FF2B5EF4-FFF2-40B4-BE49-F238E27FC236}">
-                <a16:creationId xmlns:a16="http://schemas.microsoft.com/office/drawing/2014/main" id="{BE911EA9-D2BE-4101-88A2-E27593B8BD7E}"/>
+                <a16:creationId xmlns:a16="http://schemas.microsoft.com/office/drawing/2014/main" id="{4CF930FB-1DB9-4997-A5F9-587278F064CD}"/>
               </a:ext>
             </a:extLst>
           </p:cNvPr>
@@ -12674,7 +12674,7 @@
           <p:cNvPr id="5" name="">
             <a:extLst xmlns:a="http://schemas.openxmlformats.org/drawingml/2006/main">
               <a:ext uri="{FF2B5EF4-FFF2-40B4-BE49-F238E27FC236}">
-                <a16:creationId xmlns:a16="http://schemas.microsoft.com/office/drawing/2014/main" id="{41543372-F8F7-46E6-8F97-2B1AAEC4D90E}"/>
+                <a16:creationId xmlns:a16="http://schemas.microsoft.com/office/drawing/2014/main" id="{F01EFC50-D5D6-48C6-9558-B1E413651B65}"/>
               </a:ext>
             </a:extLst>
           </p:cNvPr>
@@ -12743,7 +12743,7 @@
           <p:cNvPr id="6" name="">
             <a:extLst xmlns:a="http://schemas.openxmlformats.org/drawingml/2006/main">
               <a:ext uri="{FF2B5EF4-FFF2-40B4-BE49-F238E27FC236}">
-                <a16:creationId xmlns:a16="http://schemas.microsoft.com/office/drawing/2014/main" id="{CB5FC642-7ABF-4331-BC9A-91CB9802F273}"/>
+                <a16:creationId xmlns:a16="http://schemas.microsoft.com/office/drawing/2014/main" id="{963AECF0-6FBF-4D4A-8029-4EFF41E4BEC5}"/>
               </a:ext>
             </a:extLst>
           </p:cNvPr>
@@ -13484,7 +13484,7 @@
     </p:spTree>
     <p:extLst>
       <p:ext uri="{BB962C8B-B14F-4D97-AF65-F5344CB8AC3E}">
-        <p14:creationId xmlns:p14="http://schemas.microsoft.com/office/powerpoint/2010/main" val="1505922430"/>
+        <p14:creationId xmlns:p14="http://schemas.microsoft.com/office/powerpoint/2010/main" val="894301412"/>
       </p:ext>
     </p:extLst>
   </p:cSld>
@@ -13515,7 +13515,7 @@
           <p:cNvPr id="7" name="">
             <a:extLst xmlns:a="http://schemas.openxmlformats.org/drawingml/2006/main">
               <a:ext uri="{FF2B5EF4-FFF2-40B4-BE49-F238E27FC236}">
-                <a16:creationId xmlns:a16="http://schemas.microsoft.com/office/drawing/2014/main" id="{713B754E-0A12-4D5C-BF58-FC1CFC5E77A8}"/>
+                <a16:creationId xmlns:a16="http://schemas.microsoft.com/office/drawing/2014/main" id="{B6DE1E6F-0E8C-4460-BC49-CB8EA99331A2}"/>
               </a:ext>
             </a:extLst>
           </p:cNvPr>
@@ -13546,7 +13546,7 @@
           <p:cNvPr id="2" name="">
             <a:extLst xmlns:a="http://schemas.openxmlformats.org/drawingml/2006/main">
               <a:ext uri="{FF2B5EF4-FFF2-40B4-BE49-F238E27FC236}">
-                <a16:creationId xmlns:a16="http://schemas.microsoft.com/office/drawing/2014/main" id="{609E13E2-681E-49FE-A15D-8CC24BE7075B}"/>
+                <a16:creationId xmlns:a16="http://schemas.microsoft.com/office/drawing/2014/main" id="{0D802442-55B5-4B72-9BDA-B8A1B2184D53}"/>
               </a:ext>
             </a:extLst>
           </p:cNvPr>
@@ -13615,7 +13615,7 @@
           <p:cNvPr id="3" name="">
             <a:extLst xmlns:a="http://schemas.openxmlformats.org/drawingml/2006/main">
               <a:ext uri="{FF2B5EF4-FFF2-40B4-BE49-F238E27FC236}">
-                <a16:creationId xmlns:a16="http://schemas.microsoft.com/office/drawing/2014/main" id="{A4F46963-2904-4F0E-8B22-11A788C5F2C7}"/>
+                <a16:creationId xmlns:a16="http://schemas.microsoft.com/office/drawing/2014/main" id="{5AB1891D-790E-4B8E-9429-58777A21F383}"/>
               </a:ext>
             </a:extLst>
           </p:cNvPr>
@@ -13646,7 +13646,7 @@
           <p:cNvPr id="4" name="">
             <a:extLst xmlns:a="http://schemas.openxmlformats.org/drawingml/2006/main">
               <a:ext uri="{FF2B5EF4-FFF2-40B4-BE49-F238E27FC236}">
-                <a16:creationId xmlns:a16="http://schemas.microsoft.com/office/drawing/2014/main" id="{07FCFD78-FE16-4FCC-A649-126DD8AD9538}"/>
+                <a16:creationId xmlns:a16="http://schemas.microsoft.com/office/drawing/2014/main" id="{81083105-B482-4F7B-B28F-C2CEEFFD9960}"/>
               </a:ext>
             </a:extLst>
           </p:cNvPr>
@@ -13715,7 +13715,7 @@
           <p:cNvPr id="5" name="">
             <a:extLst xmlns:a="http://schemas.openxmlformats.org/drawingml/2006/main">
               <a:ext uri="{FF2B5EF4-FFF2-40B4-BE49-F238E27FC236}">
-                <a16:creationId xmlns:a16="http://schemas.microsoft.com/office/drawing/2014/main" id="{62FA7C26-622E-45E1-88EC-AA54CF3B10C9}"/>
+                <a16:creationId xmlns:a16="http://schemas.microsoft.com/office/drawing/2014/main" id="{BE21AE84-546D-4407-8C26-9D7F31CC0000}"/>
               </a:ext>
             </a:extLst>
           </p:cNvPr>
@@ -13784,7 +13784,7 @@
           <p:cNvPr id="6" name="">
             <a:extLst xmlns:a="http://schemas.openxmlformats.org/drawingml/2006/main">
               <a:ext uri="{FF2B5EF4-FFF2-40B4-BE49-F238E27FC236}">
-                <a16:creationId xmlns:a16="http://schemas.microsoft.com/office/drawing/2014/main" id="{9B25553C-9823-48FC-A883-9B815E9B8E26}"/>
+                <a16:creationId xmlns:a16="http://schemas.microsoft.com/office/drawing/2014/main" id="{6DB3BF33-1982-4981-9500-6B52A38554C8}"/>
               </a:ext>
             </a:extLst>
           </p:cNvPr>
@@ -14525,7 +14525,7 @@
     </p:spTree>
     <p:extLst>
       <p:ext uri="{BB962C8B-B14F-4D97-AF65-F5344CB8AC3E}">
-        <p14:creationId xmlns:p14="http://schemas.microsoft.com/office/powerpoint/2010/main" val="1641648074"/>
+        <p14:creationId xmlns:p14="http://schemas.microsoft.com/office/powerpoint/2010/main" val="2016072351"/>
       </p:ext>
     </p:extLst>
   </p:cSld>
@@ -14556,7 +14556,7 @@
           <p:cNvPr id="17" name="">
             <a:extLst xmlns:a="http://schemas.openxmlformats.org/drawingml/2006/main">
               <a:ext uri="{FF2B5EF4-FFF2-40B4-BE49-F238E27FC236}">
-                <a16:creationId xmlns:a16="http://schemas.microsoft.com/office/drawing/2014/main" id="{FA5958B3-1AEB-4D4F-9EAA-8017645DCB48}"/>
+                <a16:creationId xmlns:a16="http://schemas.microsoft.com/office/drawing/2014/main" id="{74FF8244-A7F7-4B25-BEDC-C89E35906717}"/>
               </a:ext>
             </a:extLst>
           </p:cNvPr>
@@ -14587,7 +14587,7 @@
           <p:cNvPr id="2" name="">
             <a:extLst xmlns:a="http://schemas.openxmlformats.org/drawingml/2006/main">
               <a:ext uri="{FF2B5EF4-FFF2-40B4-BE49-F238E27FC236}">
-                <a16:creationId xmlns:a16="http://schemas.microsoft.com/office/drawing/2014/main" id="{7AA7B128-F91E-4FD6-82B6-BBA6C4FB395C}"/>
+                <a16:creationId xmlns:a16="http://schemas.microsoft.com/office/drawing/2014/main" id="{B487FD4F-152D-4205-BC60-739A265DC82C}"/>
               </a:ext>
             </a:extLst>
           </p:cNvPr>
@@ -14656,7 +14656,7 @@
           <p:cNvPr id="3" name="">
             <a:extLst xmlns:a="http://schemas.openxmlformats.org/drawingml/2006/main">
               <a:ext uri="{FF2B5EF4-FFF2-40B4-BE49-F238E27FC236}">
-                <a16:creationId xmlns:a16="http://schemas.microsoft.com/office/drawing/2014/main" id="{B20B3C9E-CCDC-493D-8690-520E17C1986A}"/>
+                <a16:creationId xmlns:a16="http://schemas.microsoft.com/office/drawing/2014/main" id="{033C1211-A496-4D19-B0A5-98007B0A9043}"/>
               </a:ext>
             </a:extLst>
           </p:cNvPr>
@@ -14687,7 +14687,7 @@
           <p:cNvPr id="4" name="">
             <a:extLst xmlns:a="http://schemas.openxmlformats.org/drawingml/2006/main">
               <a:ext uri="{FF2B5EF4-FFF2-40B4-BE49-F238E27FC236}">
-                <a16:creationId xmlns:a16="http://schemas.microsoft.com/office/drawing/2014/main" id="{A8C44B0F-E3EA-4B38-9840-3CCD02BAD9C1}"/>
+                <a16:creationId xmlns:a16="http://schemas.microsoft.com/office/drawing/2014/main" id="{58176E9B-A979-445A-AEC3-3EE28D639C47}"/>
               </a:ext>
             </a:extLst>
           </p:cNvPr>
@@ -14756,7 +14756,7 @@
           <p:cNvPr id="5" name="">
             <a:extLst xmlns:a="http://schemas.openxmlformats.org/drawingml/2006/main">
               <a:ext uri="{FF2B5EF4-FFF2-40B4-BE49-F238E27FC236}">
-                <a16:creationId xmlns:a16="http://schemas.microsoft.com/office/drawing/2014/main" id="{E1E626E8-8F51-4A68-A48D-D4DA910F5E07}"/>
+                <a16:creationId xmlns:a16="http://schemas.microsoft.com/office/drawing/2014/main" id="{5BCA3D93-E0D1-47D4-AE3D-7817C6EA6738}"/>
               </a:ext>
             </a:extLst>
           </p:cNvPr>
@@ -14825,7 +14825,7 @@
           <p:cNvPr id="6" name="">
             <a:extLst xmlns:a="http://schemas.openxmlformats.org/drawingml/2006/main">
               <a:ext uri="{FF2B5EF4-FFF2-40B4-BE49-F238E27FC236}">
-                <a16:creationId xmlns:a16="http://schemas.microsoft.com/office/drawing/2014/main" id="{5DED16B2-8D82-4C2D-B30C-4EB430A9126D}"/>
+                <a16:creationId xmlns:a16="http://schemas.microsoft.com/office/drawing/2014/main" id="{F3500B10-DF60-4EAA-8E7C-364E967BE138}"/>
               </a:ext>
             </a:extLst>
           </p:cNvPr>
@@ -14894,7 +14894,7 @@
           <p:cNvPr id="7" name="">
             <a:extLst xmlns:a="http://schemas.openxmlformats.org/drawingml/2006/main">
               <a:ext uri="{FF2B5EF4-FFF2-40B4-BE49-F238E27FC236}">
-                <a16:creationId xmlns:a16="http://schemas.microsoft.com/office/drawing/2014/main" id="{18630CB7-B200-4661-BF3D-FFA4E13DC7D2}"/>
+                <a16:creationId xmlns:a16="http://schemas.microsoft.com/office/drawing/2014/main" id="{BD414FEF-386F-40CB-BA57-D1FC72BF42A7}"/>
               </a:ext>
             </a:extLst>
           </p:cNvPr>
@@ -14963,7 +14963,7 @@
           <p:cNvPr id="8" name="">
             <a:extLst xmlns:a="http://schemas.openxmlformats.org/drawingml/2006/main">
               <a:ext uri="{FF2B5EF4-FFF2-40B4-BE49-F238E27FC236}">
-                <a16:creationId xmlns:a16="http://schemas.microsoft.com/office/drawing/2014/main" id="{5113F998-CCA2-4624-B8A2-599C5ECB3F3A}"/>
+                <a16:creationId xmlns:a16="http://schemas.microsoft.com/office/drawing/2014/main" id="{FC183744-E1E2-4888-9002-9C7E3F1BF121}"/>
               </a:ext>
             </a:extLst>
           </p:cNvPr>
@@ -14994,7 +14994,7 @@
           <p:cNvPr id="9" name="">
             <a:extLst xmlns:a="http://schemas.openxmlformats.org/drawingml/2006/main">
               <a:ext uri="{FF2B5EF4-FFF2-40B4-BE49-F238E27FC236}">
-                <a16:creationId xmlns:a16="http://schemas.microsoft.com/office/drawing/2014/main" id="{2CB9A14B-502E-4A09-AFAE-DEF3104005CE}"/>
+                <a16:creationId xmlns:a16="http://schemas.microsoft.com/office/drawing/2014/main" id="{8E6E3890-3A7C-47E6-AD83-5EF2512B1392}"/>
               </a:ext>
             </a:extLst>
           </p:cNvPr>
@@ -15063,7 +15063,7 @@
           <p:cNvPr id="10" name="">
             <a:extLst xmlns:a="http://schemas.openxmlformats.org/drawingml/2006/main">
               <a:ext uri="{FF2B5EF4-FFF2-40B4-BE49-F238E27FC236}">
-                <a16:creationId xmlns:a16="http://schemas.microsoft.com/office/drawing/2014/main" id="{B7F32ACF-AE82-45C3-BBE8-7C24AD5C6E94}"/>
+                <a16:creationId xmlns:a16="http://schemas.microsoft.com/office/drawing/2014/main" id="{407CB437-944E-4777-959F-3D7AE4A87ED6}"/>
               </a:ext>
             </a:extLst>
           </p:cNvPr>
@@ -15132,7 +15132,7 @@
           <p:cNvPr id="11" name="">
             <a:extLst xmlns:a="http://schemas.openxmlformats.org/drawingml/2006/main">
               <a:ext uri="{FF2B5EF4-FFF2-40B4-BE49-F238E27FC236}">
-                <a16:creationId xmlns:a16="http://schemas.microsoft.com/office/drawing/2014/main" id="{532E5318-8DAC-4DB0-9236-4E5CF623FDB0}"/>
+                <a16:creationId xmlns:a16="http://schemas.microsoft.com/office/drawing/2014/main" id="{9E8AD40A-A281-41BF-A9BC-4B0A11C116C1}"/>
               </a:ext>
             </a:extLst>
           </p:cNvPr>
@@ -15163,7 +15163,7 @@
           <p:cNvPr id="12" name="">
             <a:extLst xmlns:a="http://schemas.openxmlformats.org/drawingml/2006/main">
               <a:ext uri="{FF2B5EF4-FFF2-40B4-BE49-F238E27FC236}">
-                <a16:creationId xmlns:a16="http://schemas.microsoft.com/office/drawing/2014/main" id="{27741F44-9123-4592-84D5-A456A0E604F3}"/>
+                <a16:creationId xmlns:a16="http://schemas.microsoft.com/office/drawing/2014/main" id="{A29402D3-20FD-4281-A81B-288F8B3E37E5}"/>
               </a:ext>
             </a:extLst>
           </p:cNvPr>
@@ -15232,7 +15232,7 @@
           <p:cNvPr id="13" name="">
             <a:extLst xmlns:a="http://schemas.openxmlformats.org/drawingml/2006/main">
               <a:ext uri="{FF2B5EF4-FFF2-40B4-BE49-F238E27FC236}">
-                <a16:creationId xmlns:a16="http://schemas.microsoft.com/office/drawing/2014/main" id="{8ED54E2B-DDA3-4FB5-8CCC-DF8F7E353A91}"/>
+                <a16:creationId xmlns:a16="http://schemas.microsoft.com/office/drawing/2014/main" id="{E02CCA50-3673-451B-B0E8-E2CC15BA51CD}"/>
               </a:ext>
             </a:extLst>
           </p:cNvPr>
@@ -15301,7 +15301,7 @@
           <p:cNvPr id="14" name="">
             <a:extLst xmlns:a="http://schemas.openxmlformats.org/drawingml/2006/main">
               <a:ext uri="{FF2B5EF4-FFF2-40B4-BE49-F238E27FC236}">
-                <a16:creationId xmlns:a16="http://schemas.microsoft.com/office/drawing/2014/main" id="{3834E192-DDC5-4E87-9E99-9F25C5C70EB1}"/>
+                <a16:creationId xmlns:a16="http://schemas.microsoft.com/office/drawing/2014/main" id="{03C07CCB-098D-4E45-9313-C47A5A0CC560}"/>
               </a:ext>
             </a:extLst>
           </p:cNvPr>
@@ -15332,7 +15332,7 @@
           <p:cNvPr id="15" name="">
             <a:extLst xmlns:a="http://schemas.openxmlformats.org/drawingml/2006/main">
               <a:ext uri="{FF2B5EF4-FFF2-40B4-BE49-F238E27FC236}">
-                <a16:creationId xmlns:a16="http://schemas.microsoft.com/office/drawing/2014/main" id="{7A97C208-C541-4EE5-933E-E7A3F07A719C}"/>
+                <a16:creationId xmlns:a16="http://schemas.microsoft.com/office/drawing/2014/main" id="{7F1DC9C1-683D-46BE-A4EB-F2CF24C8A206}"/>
               </a:ext>
             </a:extLst>
           </p:cNvPr>
@@ -15401,7 +15401,7 @@
           <p:cNvPr id="16" name="">
             <a:extLst xmlns:a="http://schemas.openxmlformats.org/drawingml/2006/main">
               <a:ext uri="{FF2B5EF4-FFF2-40B4-BE49-F238E27FC236}">
-                <a16:creationId xmlns:a16="http://schemas.microsoft.com/office/drawing/2014/main" id="{6C2E1597-5F23-4AE6-BDF5-3DD553F5D804}"/>
+                <a16:creationId xmlns:a16="http://schemas.microsoft.com/office/drawing/2014/main" id="{C9C984D2-8D32-42E7-B838-7C583AC90439}"/>
               </a:ext>
             </a:extLst>
           </p:cNvPr>
@@ -15468,7 +15468,7 @@
     </p:spTree>
     <p:extLst>
       <p:ext uri="{BB962C8B-B14F-4D97-AF65-F5344CB8AC3E}">
-        <p14:creationId xmlns:p14="http://schemas.microsoft.com/office/powerpoint/2010/main" val="126395519"/>
+        <p14:creationId xmlns:p14="http://schemas.microsoft.com/office/powerpoint/2010/main" val="2132080227"/>
       </p:ext>
     </p:extLst>
   </p:cSld>
@@ -15499,7 +15499,7 @@
           <p:cNvPr id="14" name="">
             <a:extLst xmlns:a="http://schemas.openxmlformats.org/drawingml/2006/main">
               <a:ext uri="{FF2B5EF4-FFF2-40B4-BE49-F238E27FC236}">
-                <a16:creationId xmlns:a16="http://schemas.microsoft.com/office/drawing/2014/main" id="{3AB02D01-160B-4F98-B2D5-E2FB22DBEA96}"/>
+                <a16:creationId xmlns:a16="http://schemas.microsoft.com/office/drawing/2014/main" id="{A6938645-6F94-4DE7-AAC1-A3DC06B48E14}"/>
               </a:ext>
             </a:extLst>
           </p:cNvPr>
@@ -15530,7 +15530,7 @@
           <p:cNvPr id="2" name="">
             <a:extLst xmlns:a="http://schemas.openxmlformats.org/drawingml/2006/main">
               <a:ext uri="{FF2B5EF4-FFF2-40B4-BE49-F238E27FC236}">
-                <a16:creationId xmlns:a16="http://schemas.microsoft.com/office/drawing/2014/main" id="{2721F06D-AFA1-4631-A6B6-9F36AC15AE36}"/>
+                <a16:creationId xmlns:a16="http://schemas.microsoft.com/office/drawing/2014/main" id="{1DB36A39-8EB9-492E-9034-D2E28BF7CF66}"/>
               </a:ext>
             </a:extLst>
           </p:cNvPr>
@@ -15599,7 +15599,7 @@
           <p:cNvPr id="3" name="">
             <a:extLst xmlns:a="http://schemas.openxmlformats.org/drawingml/2006/main">
               <a:ext uri="{FF2B5EF4-FFF2-40B4-BE49-F238E27FC236}">
-                <a16:creationId xmlns:a16="http://schemas.microsoft.com/office/drawing/2014/main" id="{9A4D4DAD-4010-4817-98C6-1EB5B82C6E25}"/>
+                <a16:creationId xmlns:a16="http://schemas.microsoft.com/office/drawing/2014/main" id="{45A75532-EE70-494B-A5E3-71453FAD08B3}"/>
               </a:ext>
             </a:extLst>
           </p:cNvPr>
@@ -15630,7 +15630,7 @@
           <p:cNvPr id="4" name="">
             <a:extLst xmlns:a="http://schemas.openxmlformats.org/drawingml/2006/main">
               <a:ext uri="{FF2B5EF4-FFF2-40B4-BE49-F238E27FC236}">
-                <a16:creationId xmlns:a16="http://schemas.microsoft.com/office/drawing/2014/main" id="{627A4400-07C4-4BF4-9943-1CD2E080AC40}"/>
+                <a16:creationId xmlns:a16="http://schemas.microsoft.com/office/drawing/2014/main" id="{E8617D71-287D-462E-8865-2E9711735A10}"/>
               </a:ext>
             </a:extLst>
           </p:cNvPr>
@@ -15699,7 +15699,7 @@
           <p:cNvPr id="5" name="">
             <a:extLst xmlns:a="http://schemas.openxmlformats.org/drawingml/2006/main">
               <a:ext uri="{FF2B5EF4-FFF2-40B4-BE49-F238E27FC236}">
-                <a16:creationId xmlns:a16="http://schemas.microsoft.com/office/drawing/2014/main" id="{FBE71329-CFAC-44B1-878D-1DEABFE16183}"/>
+                <a16:creationId xmlns:a16="http://schemas.microsoft.com/office/drawing/2014/main" id="{7993BDCE-D46F-424B-A848-AFD9DFF9BD21}"/>
               </a:ext>
             </a:extLst>
           </p:cNvPr>
@@ -15768,7 +15768,7 @@
           <p:cNvPr id="6" name="">
             <a:extLst xmlns:a="http://schemas.openxmlformats.org/drawingml/2006/main">
               <a:ext uri="{FF2B5EF4-FFF2-40B4-BE49-F238E27FC236}">
-                <a16:creationId xmlns:a16="http://schemas.microsoft.com/office/drawing/2014/main" id="{130B70E2-AE13-451F-879B-1E2F6D4EFCAE}"/>
+                <a16:creationId xmlns:a16="http://schemas.microsoft.com/office/drawing/2014/main" id="{DD7403C6-26AA-4F5A-BE98-FEFAB5EA9A7E}"/>
               </a:ext>
             </a:extLst>
           </p:cNvPr>
@@ -15837,7 +15837,7 @@
           <p:cNvPr id="7" name="">
             <a:extLst xmlns:a="http://schemas.openxmlformats.org/drawingml/2006/main">
               <a:ext uri="{FF2B5EF4-FFF2-40B4-BE49-F238E27FC236}">
-                <a16:creationId xmlns:a16="http://schemas.microsoft.com/office/drawing/2014/main" id="{8CD2103B-9888-4545-BF1A-9DB5BA8BF164}"/>
+                <a16:creationId xmlns:a16="http://schemas.microsoft.com/office/drawing/2014/main" id="{9E35F104-3C11-481A-ACA7-AEC7BF4651FE}"/>
               </a:ext>
             </a:extLst>
           </p:cNvPr>
@@ -15929,7 +15929,7 @@
           <p:cNvPr id="8" name="">
             <a:extLst xmlns:a="http://schemas.openxmlformats.org/drawingml/2006/main">
               <a:ext uri="{FF2B5EF4-FFF2-40B4-BE49-F238E27FC236}">
-                <a16:creationId xmlns:a16="http://schemas.microsoft.com/office/drawing/2014/main" id="{3B33D5A3-EE23-4396-94B1-8ED3475CE81C}"/>
+                <a16:creationId xmlns:a16="http://schemas.microsoft.com/office/drawing/2014/main" id="{CB042847-91CA-443C-AC3F-E29F7D1A7019}"/>
               </a:ext>
             </a:extLst>
           </p:cNvPr>
@@ -15998,7 +15998,7 @@
           <p:cNvPr id="9" name="">
             <a:extLst xmlns:a="http://schemas.openxmlformats.org/drawingml/2006/main">
               <a:ext uri="{FF2B5EF4-FFF2-40B4-BE49-F238E27FC236}">
-                <a16:creationId xmlns:a16="http://schemas.microsoft.com/office/drawing/2014/main" id="{4D269C0D-294A-4276-8F0F-9750714C12AA}"/>
+                <a16:creationId xmlns:a16="http://schemas.microsoft.com/office/drawing/2014/main" id="{88EBC2A2-10C9-43CB-99B3-70CA439A7CBB}"/>
               </a:ext>
             </a:extLst>
           </p:cNvPr>
@@ -16067,7 +16067,7 @@
           <p:cNvPr id="10" name="">
             <a:extLst xmlns:a="http://schemas.openxmlformats.org/drawingml/2006/main">
               <a:ext uri="{FF2B5EF4-FFF2-40B4-BE49-F238E27FC236}">
-                <a16:creationId xmlns:a16="http://schemas.microsoft.com/office/drawing/2014/main" id="{3871F0DC-EBD8-4335-ADD5-BE0EF210F2DC}"/>
+                <a16:creationId xmlns:a16="http://schemas.microsoft.com/office/drawing/2014/main" id="{167CD19E-BF38-42F8-9B53-D1B22B088321}"/>
               </a:ext>
             </a:extLst>
           </p:cNvPr>
@@ -16136,7 +16136,7 @@
           <p:cNvPr id="11" name="">
             <a:extLst xmlns:a="http://schemas.openxmlformats.org/drawingml/2006/main">
               <a:ext uri="{FF2B5EF4-FFF2-40B4-BE49-F238E27FC236}">
-                <a16:creationId xmlns:a16="http://schemas.microsoft.com/office/drawing/2014/main" id="{717353D8-9583-4D1E-B1D7-58A9E336C1A0}"/>
+                <a16:creationId xmlns:a16="http://schemas.microsoft.com/office/drawing/2014/main" id="{55728542-403F-47F7-A3AB-F0B687043A75}"/>
               </a:ext>
             </a:extLst>
           </p:cNvPr>
@@ -16167,7 +16167,7 @@
           <p:cNvPr id="12" name="">
             <a:extLst xmlns:a="http://schemas.openxmlformats.org/drawingml/2006/main">
               <a:ext uri="{FF2B5EF4-FFF2-40B4-BE49-F238E27FC236}">
-                <a16:creationId xmlns:a16="http://schemas.microsoft.com/office/drawing/2014/main" id="{F6E5283A-C83E-48F2-A866-0757405B41F2}"/>
+                <a16:creationId xmlns:a16="http://schemas.microsoft.com/office/drawing/2014/main" id="{22B73EF9-70E2-4FC2-A2B4-D939717CCA0C}"/>
               </a:ext>
             </a:extLst>
           </p:cNvPr>
@@ -16351,7 +16351,7 @@
           <p:cNvPr id="13" name="">
             <a:extLst xmlns:a="http://schemas.openxmlformats.org/drawingml/2006/main">
               <a:ext uri="{FF2B5EF4-FFF2-40B4-BE49-F238E27FC236}">
-                <a16:creationId xmlns:a16="http://schemas.microsoft.com/office/drawing/2014/main" id="{6B9B5D94-303A-4A9B-9299-BDC409AD0CB9}"/>
+                <a16:creationId xmlns:a16="http://schemas.microsoft.com/office/drawing/2014/main" id="{48F0A0C9-25BF-4B17-AC2C-B1A0C9AF675D}"/>
               </a:ext>
             </a:extLst>
           </p:cNvPr>
@@ -16418,7 +16418,7 @@
     </p:spTree>
     <p:extLst>
       <p:ext uri="{BB962C8B-B14F-4D97-AF65-F5344CB8AC3E}">
-        <p14:creationId xmlns:p14="http://schemas.microsoft.com/office/powerpoint/2010/main" val="204040916"/>
+        <p14:creationId xmlns:p14="http://schemas.microsoft.com/office/powerpoint/2010/main" val="849013098"/>
       </p:ext>
     </p:extLst>
   </p:cSld>
@@ -16449,7 +16449,7 @@
           <p:cNvPr id="14" name="">
             <a:extLst xmlns:a="http://schemas.openxmlformats.org/drawingml/2006/main">
               <a:ext uri="{FF2B5EF4-FFF2-40B4-BE49-F238E27FC236}">
-                <a16:creationId xmlns:a16="http://schemas.microsoft.com/office/drawing/2014/main" id="{AD9099D9-24E7-470B-927A-EADF24504F55}"/>
+                <a16:creationId xmlns:a16="http://schemas.microsoft.com/office/drawing/2014/main" id="{368EC442-531C-4415-A788-B81C858D35C6}"/>
               </a:ext>
             </a:extLst>
           </p:cNvPr>
@@ -16480,7 +16480,7 @@
           <p:cNvPr id="2" name="">
             <a:extLst xmlns:a="http://schemas.openxmlformats.org/drawingml/2006/main">
               <a:ext uri="{FF2B5EF4-FFF2-40B4-BE49-F238E27FC236}">
-                <a16:creationId xmlns:a16="http://schemas.microsoft.com/office/drawing/2014/main" id="{71EDB6E7-3006-491B-91DE-4911C64F881C}"/>
+                <a16:creationId xmlns:a16="http://schemas.microsoft.com/office/drawing/2014/main" id="{D4D87696-B645-4B92-81B3-5BC5E9248348}"/>
               </a:ext>
             </a:extLst>
           </p:cNvPr>
@@ -16549,7 +16549,7 @@
           <p:cNvPr id="3" name="">
             <a:extLst xmlns:a="http://schemas.openxmlformats.org/drawingml/2006/main">
               <a:ext uri="{FF2B5EF4-FFF2-40B4-BE49-F238E27FC236}">
-                <a16:creationId xmlns:a16="http://schemas.microsoft.com/office/drawing/2014/main" id="{B2776C8A-76EC-44EB-B75F-B6746E41C666}"/>
+                <a16:creationId xmlns:a16="http://schemas.microsoft.com/office/drawing/2014/main" id="{3A5F7443-051A-4CA0-9DFC-D23C87BCA293}"/>
               </a:ext>
             </a:extLst>
           </p:cNvPr>
@@ -16580,7 +16580,7 @@
           <p:cNvPr id="4" name="">
             <a:extLst xmlns:a="http://schemas.openxmlformats.org/drawingml/2006/main">
               <a:ext uri="{FF2B5EF4-FFF2-40B4-BE49-F238E27FC236}">
-                <a16:creationId xmlns:a16="http://schemas.microsoft.com/office/drawing/2014/main" id="{DB8278B2-214D-4861-8C90-9EAFA2CA96C4}"/>
+                <a16:creationId xmlns:a16="http://schemas.microsoft.com/office/drawing/2014/main" id="{C6B92AAB-2DEB-4D99-A59B-8FDEDDCF9662}"/>
               </a:ext>
             </a:extLst>
           </p:cNvPr>
@@ -16649,7 +16649,7 @@
           <p:cNvPr id="5" name="">
             <a:extLst xmlns:a="http://schemas.openxmlformats.org/drawingml/2006/main">
               <a:ext uri="{FF2B5EF4-FFF2-40B4-BE49-F238E27FC236}">
-                <a16:creationId xmlns:a16="http://schemas.microsoft.com/office/drawing/2014/main" id="{0112CC05-1DAA-48D2-A704-055A2A3FF2EA}"/>
+                <a16:creationId xmlns:a16="http://schemas.microsoft.com/office/drawing/2014/main" id="{4150F5F3-6C3D-49D2-8A8A-9F1537C277FC}"/>
               </a:ext>
             </a:extLst>
           </p:cNvPr>
@@ -16718,7 +16718,7 @@
           <p:cNvPr id="6" name="">
             <a:extLst xmlns:a="http://schemas.openxmlformats.org/drawingml/2006/main">
               <a:ext uri="{FF2B5EF4-FFF2-40B4-BE49-F238E27FC236}">
-                <a16:creationId xmlns:a16="http://schemas.microsoft.com/office/drawing/2014/main" id="{A204BE0A-8698-4A8C-B3B2-33D719B707A4}"/>
+                <a16:creationId xmlns:a16="http://schemas.microsoft.com/office/drawing/2014/main" id="{0C2CE600-221B-40A1-8DC8-03B347514BC4}"/>
               </a:ext>
             </a:extLst>
           </p:cNvPr>
@@ -16787,7 +16787,7 @@
           <p:cNvPr id="7" name="">
             <a:extLst xmlns:a="http://schemas.openxmlformats.org/drawingml/2006/main">
               <a:ext uri="{FF2B5EF4-FFF2-40B4-BE49-F238E27FC236}">
-                <a16:creationId xmlns:a16="http://schemas.microsoft.com/office/drawing/2014/main" id="{467B91FA-3519-499E-B36E-A400A56EA819}"/>
+                <a16:creationId xmlns:a16="http://schemas.microsoft.com/office/drawing/2014/main" id="{8F61DFD1-DE30-4B12-BCD0-250416870BFB}"/>
               </a:ext>
             </a:extLst>
           </p:cNvPr>
@@ -16879,7 +16879,7 @@
           <p:cNvPr id="8" name="">
             <a:extLst xmlns:a="http://schemas.openxmlformats.org/drawingml/2006/main">
               <a:ext uri="{FF2B5EF4-FFF2-40B4-BE49-F238E27FC236}">
-                <a16:creationId xmlns:a16="http://schemas.microsoft.com/office/drawing/2014/main" id="{2E89FF6E-3EFC-4C04-9A1B-6B5AAB06A4C2}"/>
+                <a16:creationId xmlns:a16="http://schemas.microsoft.com/office/drawing/2014/main" id="{78C5A94D-424D-4058-AD3F-580BBF8841EF}"/>
               </a:ext>
             </a:extLst>
           </p:cNvPr>
@@ -16948,7 +16948,7 @@
           <p:cNvPr id="9" name="">
             <a:extLst xmlns:a="http://schemas.openxmlformats.org/drawingml/2006/main">
               <a:ext uri="{FF2B5EF4-FFF2-40B4-BE49-F238E27FC236}">
-                <a16:creationId xmlns:a16="http://schemas.microsoft.com/office/drawing/2014/main" id="{0E11B817-EE51-4947-8A90-02C6EF94A7D7}"/>
+                <a16:creationId xmlns:a16="http://schemas.microsoft.com/office/drawing/2014/main" id="{7AAC852C-06FC-48F3-8FAD-98D3A53CE3BB}"/>
               </a:ext>
             </a:extLst>
           </p:cNvPr>
@@ -17017,7 +17017,7 @@
           <p:cNvPr id="10" name="">
             <a:extLst xmlns:a="http://schemas.openxmlformats.org/drawingml/2006/main">
               <a:ext uri="{FF2B5EF4-FFF2-40B4-BE49-F238E27FC236}">
-                <a16:creationId xmlns:a16="http://schemas.microsoft.com/office/drawing/2014/main" id="{E36C8E8A-B019-4555-BD04-70B70E2CAED1}"/>
+                <a16:creationId xmlns:a16="http://schemas.microsoft.com/office/drawing/2014/main" id="{AE00D77D-09F1-4874-BFA0-A66AFDDF3CE0}"/>
               </a:ext>
             </a:extLst>
           </p:cNvPr>
@@ -17086,7 +17086,7 @@
           <p:cNvPr id="11" name="">
             <a:extLst xmlns:a="http://schemas.openxmlformats.org/drawingml/2006/main">
               <a:ext uri="{FF2B5EF4-FFF2-40B4-BE49-F238E27FC236}">
-                <a16:creationId xmlns:a16="http://schemas.microsoft.com/office/drawing/2014/main" id="{D17B43A6-DE83-440B-ADF5-26D629805DD3}"/>
+                <a16:creationId xmlns:a16="http://schemas.microsoft.com/office/drawing/2014/main" id="{DCF46AD2-336B-4E0E-A8DB-743E9B9EC018}"/>
               </a:ext>
             </a:extLst>
           </p:cNvPr>
@@ -17117,7 +17117,7 @@
           <p:cNvPr id="12" name="">
             <a:extLst xmlns:a="http://schemas.openxmlformats.org/drawingml/2006/main">
               <a:ext uri="{FF2B5EF4-FFF2-40B4-BE49-F238E27FC236}">
-                <a16:creationId xmlns:a16="http://schemas.microsoft.com/office/drawing/2014/main" id="{041F4C20-F779-4097-8E96-80DD24F2F4CB}"/>
+                <a16:creationId xmlns:a16="http://schemas.microsoft.com/office/drawing/2014/main" id="{AB3DA715-F231-47FF-8537-9469F4B852E0}"/>
               </a:ext>
             </a:extLst>
           </p:cNvPr>
@@ -17283,7 +17283,7 @@
           <p:cNvPr id="13" name="">
             <a:extLst xmlns:a="http://schemas.openxmlformats.org/drawingml/2006/main">
               <a:ext uri="{FF2B5EF4-FFF2-40B4-BE49-F238E27FC236}">
-                <a16:creationId xmlns:a16="http://schemas.microsoft.com/office/drawing/2014/main" id="{526F385B-0E98-4F1B-94AC-EC756433256C}"/>
+                <a16:creationId xmlns:a16="http://schemas.microsoft.com/office/drawing/2014/main" id="{6C2CD45F-913C-44FC-BC2E-37AE2E5BB3B5}"/>
               </a:ext>
             </a:extLst>
           </p:cNvPr>
@@ -17350,7 +17350,7 @@
     </p:spTree>
     <p:extLst>
       <p:ext uri="{BB962C8B-B14F-4D97-AF65-F5344CB8AC3E}">
-        <p14:creationId xmlns:p14="http://schemas.microsoft.com/office/powerpoint/2010/main" val="1448095931"/>
+        <p14:creationId xmlns:p14="http://schemas.microsoft.com/office/powerpoint/2010/main" val="1793264974"/>
       </p:ext>
     </p:extLst>
   </p:cSld>

</xml_diff>